<commit_message>
Starbucks deck: Thai slides keep English terms
Brand names, places and business terms (Third Place, Touchpoint, Starbucks,
Milan, Omnichannel…) stay in English on the Thai slides; Thai carries the
sentence. Adds make-thai-web.py so the web app's Thai slides are generated
from the same dictionary. Exports rebuilt.

Co-Authored-By: Claude Fable 5.1 <noreply@anthropic.com>
Claude-Session: https://claude.ai/code/session_01MJB3WpVo3kuH25GjttwApw
</commit_message>
<xml_diff>
--- a/starbucks-presentation/export/Starbucks_Storytelling_Masterclass.pptx
+++ b/starbucks-presentation/export/Starbucks_Storytelling_Masterclass.pptx
@@ -122,31 +122,31 @@
   <p:extLst>
     <p:ext uri="{521415D9-36F7-43E2-AB2F-B90AF26B5E84}">
       <p14:sectionLst xmlns:p14="http://schemas.microsoft.com/office/powerpoint/2010/main">
-        <p14:section name="Part 1: the foundation and origin of the brand in 1971 Seattle." id="{9e2040ac-476e-a6bd-8f17-bbe9258dfe93}">
+        <p14:section name="Part 1: the foundation and origin of the brand in 1971 Seattle." id="{dee86844-ef3a-93fa-24e8-d694375f7652}">
           <p14:sldIdLst>
             <p14:sldId id="256"/>
             <p14:sldId id="257"/>
           </p14:sldIdLst>
         </p14:section>
-        <p14:section name="Part 2: the Milan turning point and the Third Place concept." id="{14576113-f468-3328-4d6f-51d5a2ff05e1}">
+        <p14:section name="Part 2: the Milan turning point and the Third Place concept." id="{58a65957-7b90-71b9-4ed0-55be9114382d}">
           <p14:sldIdLst>
             <p14:sldId id="258"/>
             <p14:sldId id="259"/>
           </p14:sldIdLst>
         </p14:section>
-        <p14:section name="Part 3: scaling the experience through touchpoints and digital." id="{9474f90e-4a25-f195-7953-cf84ce507926}">
+        <p14:section name="Part 3: scaling the experience through touchpoints and digital." id="{173a0233-b738-9392-7191-b329249de721}">
           <p14:sldIdLst>
             <p14:sldId id="260"/>
             <p14:sldId id="261"/>
           </p14:sldIdLst>
         </p14:section>
-        <p14:section name="Part 4: global impact and the MBA takeaways." id="{eaa3294e-95c0-b2c5-0d9f-9cfe26788148}">
+        <p14:section name="Part 4: global impact and the MBA takeaways." id="{8deb4591-9537-e5b5-855b-0353f1bec46e}">
           <p14:sldIdLst>
             <p14:sldId id="262"/>
             <p14:sldId id="263"/>
           </p14:sldIdLst>
         </p14:section>
-        <p14:section name="Thai version: slides 9-16 repeat the whole story in Thai (ฉบับภาษาไทย)." id="{b05ef708-a55b-d61a-f7af-fd9ba4fc23a5}">
+        <p14:section name="Thai version: slides 9-16 repeat the whole story in Thai (ฉบับภาษาไทย)." id="{872d135e-7ddb-417d-4e82-7d22824a9ce2}">
           <p14:sldIdLst>
             <p14:sldId id="264"/>
             <p14:sldId id="265"/>
@@ -650,7 +650,7 @@
           <a:p>
             <a:r>
               <a:rPr lang="en-US" dirty="0"/>
-              <a:t>ก่อนยุคลาเต้ สตาร์บัคส์เป็นร้านค้าปลีกเมล็ดกาแฟและเครื่องเทศระดับไฮเอนด์ ก่อตั้งในปี 1971 โดย Jerry Baldwin, Zev Siegl และ Gordon Bowker ด้วยพันธกิจที่เรียบง่าย: สอนให้คนอเมริกันชงกาแฟคั่วเข้มชั้นดีได้เองที่บ้าน ชื่อและโลโก้ก็เป็นการเล่าเรื่องตั้งแต่แรก: ไซเรนสองหางมาจากภาพแกะไม้นอร์สสมัยศตวรรษที่ 16 สื่อถึงประเพณีการเดินเรือของซีแอตเทิลและเสน่ห์ของกาแฟชั้นดีที่ยากจะต้านทาน เวทีถูกจัดเตรียมไว้แล้ว แต่สตาร์บัคส์ยังขาดส่วนผสมวิเศษที่สำคัญที่สุด จนกระทั่งปี 1983 กับการเดินทางไปมิลาน</a:t>
+              <a:t>ก่อนยุค Latte Starbucks เป็นร้านขายเมล็ดกาแฟและเครื่องเทศระดับ High-End ก่อตั้งในปี 1971 โดย Jerry Baldwin, Zev Siegl และ Gordon Bowker ด้วย Mission ที่เรียบง่าย: สอนให้คนอเมริกันชงกาแฟ Dark Roast ชั้นดีได้เองที่บ้าน ชื่อและโลโก้ก็เป็น Storytelling ตั้งแต่แรก: Siren สองหางมาจากภาพแกะไม้แบบ Norse สมัยศตวรรษที่ 16 สื่อถึงประเพณีการเดินเรือของ Seattle และเสน่ห์ของกาแฟชั้นดีที่ยากจะต้านทาน เวทีพร้อมแล้ว แต่ Starbucks ยังขาดส่วนผสมวิเศษที่สำคัญที่สุด จนกระทั่งปี 1983 กับทริปไป Milan</a:t>
             </a:r>
             <a:endParaRPr lang="en-US" dirty="0"/>
           </a:p>
@@ -738,7 +738,7 @@
           <a:p>
             <a:r>
               <a:rPr lang="en-US" dirty="0"/>
-              <a:t>ในปี 1983 โฮเวิร์ด ชูลต์ซ ไปเยือนบาร์เอสเพรสโซในมิลาน เขาสังเกตว่าร้านเหล่านั้นไม่ได้แค่ขายเครื่องดื่ม แต่เป็นห้องนั่งเล่นของชุมชนที่มีชีวิตชีวา วิสัยทัศน์ของเขาคืออเมริกาต้องการวัฒนธรรมเอสเพรสโซแท้ ๆ ที่สร้างขึ้นจากการเชื่อมโยงระหว่างผู้คน ความรวดเร็ว และฝีมือ ในปี 1987 เขาซื้อสตาร์บัคส์ในราคา 3.8 ล้านดอลลาร์ และรวมแนวคิดร้าน Il Giornale ของเขาเข้าไป เปิดศักราชร้านกาแฟยุคใหม่ ชูลต์ซไม่ได้แค่อยากขายกาแฟ เขาอยากสร้างพื้นที่ใหม่ในชีวิตของผู้คน</a:t>
+              <a:t>ในปี 1983 Howard Schultz ไปเยือน Espresso Bar ใน Milan เขาสังเกตว่าร้านเหล่านั้นไม่ได้แค่ขายเครื่องดื่ม แต่เป็น Community Living Room ที่มีชีวิตชีวา Vision ของเขาคืออเมริกาต้องการวัฒนธรรม Espresso แท้ ๆ ที่สร้างจาก Human Connection, Speed และ Craftsmanship ในปี 1987 เขาซื้อ Starbucks ในราคา 3.8 ล้านดอลลาร์ และรวม Concept ร้าน Il Giornale ของเขาเข้าไป เปิดศักราช Coffeehouse ยุคใหม่ Schultz ไม่ได้แค่อยากขายกาแฟ เขาอยากสร้างพื้นที่ใหม่ในชีวิตของผู้คน</a:t>
             </a:r>
             <a:endParaRPr lang="en-US" dirty="0"/>
           </a:p>
@@ -826,7 +826,7 @@
           <a:p>
             <a:r>
               <a:rPr lang="en-US" dirty="0"/>
-              <a:t>คำตอบของชูลต์ซคือบ้านหลังที่สาม บ้านคือที่หนึ่ง ที่ทำงานคือที่สอง และสตาร์บัคส์คือที่สาม: ที่พักพิงอันอบอุ่น ปราศจากความกดดัน ระหว่างสองที่นั้น เสาหลักที่สองคือความผูกพันทางอารมณ์ ดังคำของชูลต์ซ: เราไม่ได้อยู่ในธุรกิจกาแฟที่ให้บริการผู้คน แต่เราอยู่ในธุรกิจผู้คนที่ให้บริการกาแฟ เสาหลักที่สามมองบรรยากาศเป็นผลิตภัณฑ์: แสงไฟอบอุ่น พื้นผิวไม้ ดนตรีอะคูสติก และกลิ่นหอมชวนต้อนรับ เมื่อเข้าใจบ้านหลังที่สามแล้ว สตาร์บัคส์ขยายประสบการณ์แบบมนุษย์นี้ไปสู่ร้านหลายพันสาขาได้อย่างไร</a:t>
+              <a:t>คำตอบของ Schultz คือ The Third Place บ้านคือ 1st Place ที่ทำงานคือ 2nd Place และ Starbucks คือ 3rd Place: ที่พักพิงอันอบอุ่น ไร้ความกดดัน ระหว่างสองที่นั้น Pillar ที่สองคือ Emotional Connection ดังคำของ Schultz: เราไม่ได้อยู่ในธุรกิจกาแฟที่ให้บริการผู้คน แต่เราอยู่ในธุรกิจผู้คนที่ให้บริการกาแฟ Pillar ที่สามมอง Atmosphere เป็น Product: แสงไฟอบอุ่น Texture ไม้ ดนตรี Acoustic และกลิ่นหอมชวนต้อนรับ เมื่อเข้าใจ Third Place แล้ว Starbucks ขยาย Human Experience นี้ไปสู่ร้านหลายพันสาขาได้อย่างไร</a:t>
             </a:r>
             <a:endParaRPr lang="en-US" dirty="0"/>
           </a:p>
@@ -914,7 +914,7 @@
           <a:p>
             <a:r>
               <a:rPr lang="en-US" dirty="0"/>
-              <a:t>จะรักษาประสบการณ์แบบมนุษย์ไว้ในร้านหลายพันสาขาได้อย่างไร ผ่านจุดสัมผัสในชีวิตประจำวัน หนึ่ง ความเป็นส่วนตัวและการเชื่อมโยง: ชื่อบนแก้ว บาริสต้าสบตา และเครื่องดื่มที่ปรับแต่งด้วยมือ สอง ความสม่ำเสมอทางประสาทสัมผัส: การออกแบบบรรยากาศ กลิ่นเอกลักษณ์ และเพลย์ลิสต์เดียวกันในร้านทั่วโลก สาม ปรับให้เข้ากับชุมชน: สถาปัตยกรรมร้านสะท้อนมรดกของย่าน ขณะที่คุณค่าหลักของแบรนด์คงเดิม เมื่อไลฟ์สไตล์ของลูกค้าเปลี่ยนไป สตาร์บัคส์ต้องพาบ้านหลังที่สามเข้าสู่ยุคดิจิทัล</a:t>
+              <a:t>จะรักษา Human Experience ไว้ในร้านหลายพันสาขาได้อย่างไร ผ่าน Touchpoint ในชีวิตประจำวัน หนึ่ง Personalization และ Connection: ชื่อบนแก้ว Barista สบตา และเครื่องดื่ม Handcrafted ที่ Customize ได้ สอง Sensory Consistency: Ambient Design กลิ่น Signature และ Playlist เดียวกันในร้านทั่วโลก สาม Community Customization: สถาปัตยกรรมร้านสะท้อน Heritage ของย่าน ขณะที่ Core Values ของแบรนด์คงเดิม เมื่อ Lifestyle ของลูกค้าเปลี่ยนไป Starbucks ต้องพา Third Place เข้าสู่ยุค Digital</a:t>
             </a:r>
             <a:endParaRPr lang="en-US" dirty="0"/>
           </a:p>
@@ -1002,7 +1002,7 @@
           <a:p>
             <a:r>
               <a:rPr lang="en-US" dirty="0"/>
-              <a:t>ฝั่งดิจิทัลต่อยอดแนวคิดเดียวกัน แอป Starbucks Rewards เป็นโปรแกรมสะสมคะแนนแบบเกมที่มีสมาชิกใช้งานกว่า 30 ล้านคน Mobile Order and Pay ตัดความยุ่งยากออกจากการมาร้าน การปรับแต่งเฉพาะบุคคลใช้ระบบแนะนำด้วย AI ปรับข้อเสนอให้ตรงรสนิยมแต่ละคน และโมเดลออมนิแชนแนลรักษาการเชื่อมโยงกับผู้คนไว้แม้ผ่านไดรฟ์ทรูและเดลิเวอรี เมื่อเชี่ยวชาญทั้งประสบการณ์หน้าร้านและนวัตกรรมดิจิทัลแล้ว ผลกระทบทางธุรกิจระดับโลกเป็นอย่างไร</a:t>
+              <a:t>ฝั่ง Digital ต่อยอด Concept เดียวกัน แอป Starbucks Rewards เป็น Loyalty Program แบบ Gamified ที่มี Active Member กว่า 30 ล้านคน Mobile Order and Pay ตัด Friction ออกจากการมาร้าน Digital Personalization ใช้ Recommendation Engine ที่ขับเคลื่อนด้วย AI ปรับข้อเสนอให้ตรงรสนิยมแต่ละคน และโมเดล Omnichannel รักษา Human Connection ไว้แม้ผ่าน Drive-thru และ Delivery เมื่อเชี่ยวชาญทั้ง Physical Experience และ Digital Innovation แล้ว Global Business Impact เป็นอย่างไร</a:t>
             </a:r>
             <a:endParaRPr lang="en-US" dirty="0"/>
           </a:p>
@@ -1090,7 +1090,7 @@
           <a:p>
             <a:r>
               <a:rPr lang="en-US" dirty="0"/>
-              <a:t>วันนี้เรื่องราวนี้ถูกเล่าในร้านกว่า 38,000 สาขา ในกว่า 80 ตลาดทั่วโลก สามกลยุทธ์ที่ทำให้ขยายได้ขนาดนี้: การร่วมทุนเชิงกลยุทธ์กับพันธมิตรท้องถิ่นเปิดตลาดใหม่ การปรับให้เข้ากับแต่ละตลาดปรับเมนู เช่น Teavana และเครื่องดื่มมัทฉะในเอเชีย และ Reserve Roasteries ระดับไฮเอนด์ทำหน้าที่เป็นแฟล็กชิปนักเล่าเรื่องของทั้งแบรนด์ แล้วผู้นำธุรกิจเรียนรู้อะไรได้บ้างจากเรื่องราวนี้</a:t>
+              <a:t>วันนี้เรื่องราวนี้ถูกเล่าในร้านกว่า 38,000 สาขา ในกว่า 80 ตลาดทั่วโลก สามกลยุทธ์ที่ทำให้ขยายได้ขนาดนี้: Strategic Joint Venture กับ Partner ท้องถิ่นเปิดตลาดใหม่ Market Customization ปรับเมนู เช่น Teavana และเครื่องดื่ม Matcha ในเอเชีย และ Reserve Roasteries ระดับ High-End ทำหน้าที่เป็น Flagship Storyteller ของทั้งแบรนด์ แล้ว Business Leader เรียนรู้อะไรได้บ้างจากเรื่องราวนี้</a:t>
             </a:r>
             <a:endParaRPr lang="en-US" dirty="0"/>
           </a:p>
@@ -1178,7 +1178,7 @@
           <a:p>
             <a:r>
               <a:rPr lang="en-US" dirty="0"/>
-              <a:t>สามบทเรียนสำหรับผู้นำธุรกิจ หนึ่ง ผลิตภัณฑ์กับประสบการณ์: ผลิตภัณฑ์ถูกทำให้เป็นสินค้าโภคภัณฑ์ได้ แต่ประสบการณ์แบรนด์สร้างคูเมืองทางการแข่งขัน สอง ความจริงใจและความสม่ำเสมอ: คุณค่าหลักของแบรนด์ต้องคงเดิมแม้ขยายตัวทั่วโลกอย่างรวดเร็ว สาม ความสามารถในการปรับตัวเชิงกลยุทธ์: สตาร์บัคส์ผสานบรรยากาศบ้านหลังที่สามเข้ากับระบบนิเวศดิจิทัลล้ำสมัย ขอปิดท้ายด้วยข้อคิดนี้: ในโลกที่เป็นดิจิทัลและโดดเดี่ยวมากขึ้นทุกที ความโหยหาการเชื่อมโยงที่แท้จริงระหว่างมนุษย์ไม่เคยยิ่งใหญ่เท่านี้มาก่อน ขอบคุณครับ/ค่ะ ยินดีรับทุกคำถามจากเพื่อน ๆ ในชั้นเรียน</a:t>
+              <a:t>สามบทเรียนสำหรับ Business Leader หนึ่ง Product กับ Experience: Product ถูกทำให้เป็น Commodity ได้ แต่ Brand Experience สร้าง Competitive Moat สอง Authenticity และ Consistency: Core Brand Values ต้องคงเดิมแม้ขยายทั่วโลกอย่างรวดเร็ว สาม Strategic Adaptability: Starbucks ผสานบรรยากาศ Third Place แบบ Physical เข้ากับ Digital Ecosystem ที่ล้ำสมัย ขอปิดท้ายด้วยข้อคิดนี้: ในโลกที่ Digital และโดดเดี่ยวมากขึ้นทุกที ความโหยหา Human Connection ที่แท้จริงไม่เคยยิ่งใหญ่เท่านี้มาก่อน ขอบคุณครับ/ค่ะ ยินดีรับทุกคำถามจากเพื่อน ๆ ในชั้นเรียน</a:t>
             </a:r>
             <a:endParaRPr lang="en-US" dirty="0"/>
           </a:p>
@@ -1882,7 +1882,7 @@
           <a:p>
             <a:r>
               <a:rPr lang="en-US" dirty="0"/>
-              <a:t>สวัสดีทุกคน หัวข้อของเราคือสตาร์บัคส์ใช้การเล่าเรื่องอย่างไรในการเติบโตจากร้านเดียวในซีแอตเทิลสู่แบรนด์ระดับโลก เราจะเล่าเป็นสี่ตอน: จุดกำเนิด จุดเปลี่ยน การนำประสบการณ์ไปปฏิบัติจริง และผลกระทบระดับโลกพร้อมบทเรียนสำหรับผู้นำธุรกิจ สามสิ่งที่อยากให้จำไว้ตั้งแต่ต้น: จุดเริ่มต้นในปี 1971 ที่ตลาดไพก์เพลซ ผลิตภัณฑ์คือกาแฟเมล็ดคั่วระดับกูร์เมต์ และสัญลักษณ์คือไซเรนสองหาง ต่อไป เรามาดูกันว่าทุกอย่างเริ่มต้นที่ไหนในปี 1971</a:t>
+              <a:t>สวัสดีทุกคน หัวข้อของเราคือ Starbucks ใช้ Storytelling อย่างไรในการเติบโตจากร้านเดียวใน Seattle สู่แบรนด์ระดับโลก เราจะเล่าเป็นสี่ Part: จุดกำเนิด จุดเปลี่ยน การนำ Experience ไปปฏิบัติจริง และ Global Impact พร้อมบทเรียนสำหรับ Business Leader สามสิ่งที่อยากให้จำไว้ตั้งแต่ต้น: จุดเริ่มต้นในปี 1971 ที่ Pike Place Market ผลิตภัณฑ์คือ Whole-Bean Gourmet Coffee และสัญลักษณ์คือ Siren สองหาง ต่อไป มาดูกันว่าทุกอย่างเริ่มต้นที่ไหนในปี 1971</a:t>
             </a:r>
             <a:endParaRPr lang="en-US" dirty="0"/>
           </a:p>
@@ -4473,7 +4473,7 @@
                 <a:ea typeface="Pridi" pitchFamily="34" charset="-122"/>
                 <a:cs typeface="Pridi" pitchFamily="34" charset="-120"/>
               </a:rPr>
-              <a:t>บทที่ 1: เมล็ดกาแฟและรากเหง้าในซีแอตเทิล</a:t>
+              <a:t>บทที่ 1: Coffee Beans &amp; Seattle Roots</a:t>
             </a:r>
             <a:endParaRPr lang="en-US" sz="2175" dirty="0"/>
           </a:p>
@@ -4515,7 +4515,7 @@
                 <a:ea typeface="Sarabun" pitchFamily="34" charset="-122"/>
                 <a:cs typeface="Sarabun" pitchFamily="34" charset="-120"/>
               </a:rPr>
-              <a:t>ก่อนยุคลาเต้: ร้านค้าปลีกเมล็ดกาแฟและเครื่องเทศระดับไฮเอนด์</a:t>
+              <a:t>ก่อนยุค Latte: ร้านขายเมล็ดกาแฟและเครื่องเทศระดับ High-End</a:t>
             </a:r>
             <a:endParaRPr lang="en-US" sz="1200" dirty="0"/>
           </a:p>
@@ -4557,7 +4557,7 @@
                 <a:ea typeface="Sarabun" pitchFamily="34" charset="-122"/>
                 <a:cs typeface="Sarabun" pitchFamily="34" charset="-120"/>
               </a:rPr>
-              <a:t>ตอนที่ 1 · รากฐานและจุดกำเนิด</a:t>
+              <a:t>Part 1 · รากฐานและจุดกำเนิดของแบรนด์</a:t>
             </a:r>
             <a:endParaRPr lang="en-US" sz="900" dirty="0"/>
           </a:p>
@@ -4621,7 +4621,7 @@
                 <a:ea typeface="Sarabun" pitchFamily="34" charset="-122"/>
                 <a:cs typeface="Sarabun" pitchFamily="34" charset="-120"/>
               </a:rPr>
-              <a:t>1971 · ไพก์เพลซ ซีแอตเทิล</a:t>
+              <a:t>1971 · Pike Place, Seattle</a:t>
             </a:r>
             <a:endParaRPr lang="en-US" sz="900" dirty="0"/>
           </a:p>
@@ -4716,7 +4716,7 @@
         <p:spPr>
           <a:xfrm>
             <a:off x="1147763" y="1919287"/>
-            <a:ext cx="970514" cy="171450"/>
+            <a:ext cx="926634" cy="171450"/>
           </a:xfrm>
           <a:prstGeom prst="rect">
             <a:avLst/>
@@ -4743,7 +4743,7 @@
                 <a:ea typeface="Sarabun" pitchFamily="34" charset="-122"/>
                 <a:cs typeface="Sarabun" pitchFamily="34" charset="-120"/>
               </a:rPr>
-              <a:t>ผู้ก่อตั้งและพันธกิจ</a:t>
+              <a:t>ผู้ก่อตั้ง &amp; Mission</a:t>
             </a:r>
             <a:endParaRPr lang="en-US" sz="900" dirty="0"/>
           </a:p>
@@ -5034,7 +5034,7 @@
                 <a:ea typeface="Sarabun" pitchFamily="34" charset="-122"/>
                 <a:cs typeface="Sarabun" pitchFamily="34" charset="-120"/>
               </a:rPr>
-              <a:t>พันธกิจ</a:t>
+              <a:t>Mission</a:t>
             </a:r>
             <a:endParaRPr lang="en-US" sz="900" dirty="0"/>
           </a:p>
@@ -5076,7 +5076,7 @@
                 <a:ea typeface="Sarabun" pitchFamily="34" charset="-122"/>
                 <a:cs typeface="Sarabun" pitchFamily="34" charset="-120"/>
               </a:rPr>
-              <a:t>สอนให้คนอเมริกันชงกาแฟ</a:t>
+              <a:t>สอนให้คนอเมริกันชงกาแฟ </a:t>
             </a:r>
             <a:pPr algn="l" indent="0" marL="0">
               <a:lnSpc>
@@ -5093,7 +5093,7 @@
                 <a:ea typeface="Sarabun" pitchFamily="34" charset="-122"/>
                 <a:cs typeface="Sarabun" pitchFamily="34" charset="-120"/>
               </a:rPr>
-              <a:t>คั่วเข้ม</a:t>
+              <a:t>Dark Roast</a:t>
             </a:r>
             <a:pPr algn="l" indent="0" marL="0">
               <a:lnSpc>
@@ -5110,7 +5110,7 @@
                 <a:ea typeface="Sarabun" pitchFamily="34" charset="-122"/>
                 <a:cs typeface="Sarabun" pitchFamily="34" charset="-120"/>
               </a:rPr>
-              <a:t>ชั้นดีได้เองที่บ้าน</a:t>
+              <a:t> ชั้นดีได้เองที่บ้าน</a:t>
             </a:r>
             <a:endParaRPr lang="en-US" sz="1013" dirty="0"/>
           </a:p>
@@ -5186,7 +5186,7 @@
                 <a:ea typeface="Sarabun" pitchFamily="34" charset="-122"/>
                 <a:cs typeface="Sarabun" pitchFamily="34" charset="-120"/>
               </a:rPr>
-              <a:t>ตำนานไซเรน</a:t>
+              <a:t>ตำนาน Siren</a:t>
             </a:r>
             <a:endParaRPr lang="en-US" sz="900" dirty="0"/>
           </a:p>
@@ -5270,7 +5270,7 @@
                 <a:ea typeface="Pridi" pitchFamily="34" charset="-122"/>
                 <a:cs typeface="Pridi" pitchFamily="34" charset="-120"/>
               </a:rPr>
-              <a:t>ภาพแกะไม้ไซเรนนอร์สสมัยศตวรรษที่ 16</a:t>
+              <a:t>ภาพแกะไม้ Siren แบบ Norse สมัยศตวรรษที่ 16</a:t>
             </a:r>
             <a:endParaRPr lang="en-US" sz="1200" dirty="0"/>
           </a:p>
@@ -5334,7 +5334,7 @@
                 <a:ea typeface="Sarabun" pitchFamily="34" charset="-122"/>
                 <a:cs typeface="Sarabun" pitchFamily="34" charset="-120"/>
               </a:rPr>
-              <a:t>ประเพณีการเดินเรือของซีแอตเทิล</a:t>
+              <a:t>ประเพณีการเดินเรือของ Seattle</a:t>
             </a:r>
             <a:endParaRPr lang="en-US" sz="1050" dirty="0"/>
           </a:p>
@@ -5528,7 +5528,7 @@
                 <a:ea typeface="Sarabun" pitchFamily="34" charset="-122"/>
                 <a:cs typeface="Sarabun" pitchFamily="34" charset="-120"/>
               </a:rPr>
-              <a:t>เวทีถูกจัดเตรียมไว้แล้ว แต่สตาร์บัคส์ยังขาดส่วนผสมวิเศษที่สำคัญที่สุด… จนกระทั่งปี </a:t>
+              <a:t>เวทีพร้อมแล้ว แต่ Starbucks ยังขาดส่วนผสมวิเศษที่สำคัญที่สุด… จนกระทั่งปี </a:t>
             </a:r>
             <a:pPr algn="l" indent="0" marL="0">
               <a:lnSpc>
@@ -5562,7 +5562,7 @@
                 <a:ea typeface="Sarabun" pitchFamily="34" charset="-122"/>
                 <a:cs typeface="Sarabun" pitchFamily="34" charset="-120"/>
               </a:rPr>
-              <a:t> กับการเดินทางไป</a:t>
+              <a:t> กับทริปไป </a:t>
             </a:r>
             <a:pPr algn="l" indent="0" marL="0">
               <a:lnSpc>
@@ -5579,7 +5579,7 @@
                 <a:ea typeface="Sarabun" pitchFamily="34" charset="-122"/>
                 <a:cs typeface="Sarabun" pitchFamily="34" charset="-120"/>
               </a:rPr>
-              <a:t>มิลาน</a:t>
+              <a:t>Milan</a:t>
             </a:r>
             <a:endParaRPr lang="en-US" sz="1013" dirty="0"/>
           </a:p>
@@ -5643,7 +5643,7 @@
                 <a:ea typeface="Sarabun" pitchFamily="34" charset="-122"/>
                 <a:cs typeface="Sarabun" pitchFamily="34" charset="-120"/>
               </a:rPr>
-              <a:t>1983 · การเดินทางไปมิลาน</a:t>
+              <a:t>1983 · ทริปไป Milan</a:t>
             </a:r>
             <a:endParaRPr lang="en-US" sz="900" dirty="0"/>
           </a:p>
@@ -5658,7 +5658,7 @@
         <p:spPr>
           <a:xfrm>
             <a:off x="609600" y="4667250"/>
-            <a:ext cx="2170584" cy="171450"/>
+            <a:ext cx="2612678" cy="171450"/>
           </a:xfrm>
           <a:prstGeom prst="rect">
             <a:avLst/>
@@ -5685,7 +5685,7 @@
                 <a:ea typeface="Sarabun" pitchFamily="34" charset="-122"/>
                 <a:cs typeface="Sarabun" pitchFamily="34" charset="-120"/>
               </a:rPr>
-              <a:t>สไลด์ 2 จาก 8 · ตอนที่ 1 · รากฐานและจุดกำเนิด</a:t>
+              <a:t>สไลด์ 2 จาก 8 · Part 1 · รากฐานและจุดกำเนิดของแบรนด์</a:t>
             </a:r>
             <a:endParaRPr lang="en-US" sz="900" dirty="0"/>
           </a:p>
@@ -5699,7 +5699,7 @@
         </p:nvSpPr>
         <p:spPr>
           <a:xfrm>
-            <a:off x="2970684" y="4724400"/>
+            <a:off x="3412778" y="4724400"/>
             <a:ext cx="57150" cy="57150"/>
           </a:xfrm>
           <a:prstGeom prst="roundRect">
@@ -5721,7 +5721,7 @@
         </p:nvSpPr>
         <p:spPr>
           <a:xfrm>
-            <a:off x="3075459" y="4724400"/>
+            <a:off x="3517553" y="4724400"/>
             <a:ext cx="171450" cy="57150"/>
           </a:xfrm>
           <a:prstGeom prst="roundRect">
@@ -5743,7 +5743,7 @@
         </p:nvSpPr>
         <p:spPr>
           <a:xfrm>
-            <a:off x="3294534" y="4724400"/>
+            <a:off x="3736628" y="4724400"/>
             <a:ext cx="57150" cy="57150"/>
           </a:xfrm>
           <a:prstGeom prst="roundRect">
@@ -5765,7 +5765,7 @@
         </p:nvSpPr>
         <p:spPr>
           <a:xfrm>
-            <a:off x="3399309" y="4724400"/>
+            <a:off x="3841403" y="4724400"/>
             <a:ext cx="57150" cy="57150"/>
           </a:xfrm>
           <a:prstGeom prst="roundRect">
@@ -5787,7 +5787,7 @@
         </p:nvSpPr>
         <p:spPr>
           <a:xfrm>
-            <a:off x="3504084" y="4724400"/>
+            <a:off x="3946178" y="4724400"/>
             <a:ext cx="57150" cy="57150"/>
           </a:xfrm>
           <a:prstGeom prst="roundRect">
@@ -5809,7 +5809,7 @@
         </p:nvSpPr>
         <p:spPr>
           <a:xfrm>
-            <a:off x="3608859" y="4724400"/>
+            <a:off x="4050953" y="4724400"/>
             <a:ext cx="57150" cy="57150"/>
           </a:xfrm>
           <a:prstGeom prst="roundRect">
@@ -5831,7 +5831,7 @@
         </p:nvSpPr>
         <p:spPr>
           <a:xfrm>
-            <a:off x="3713634" y="4724400"/>
+            <a:off x="4155728" y="4724400"/>
             <a:ext cx="57150" cy="57150"/>
           </a:xfrm>
           <a:prstGeom prst="roundRect">
@@ -5853,7 +5853,7 @@
         </p:nvSpPr>
         <p:spPr>
           <a:xfrm>
-            <a:off x="3818409" y="4724400"/>
+            <a:off x="4260503" y="4724400"/>
             <a:ext cx="57150" cy="57150"/>
           </a:xfrm>
           <a:prstGeom prst="roundRect">
@@ -7538,7 +7538,7 @@
                 <a:ea typeface="Pridi" pitchFamily="34" charset="-122"/>
                 <a:cs typeface="Pridi" pitchFamily="34" charset="-120"/>
               </a:rPr>
-              <a:t>บทที่ 2: แรงบันดาลใจจากอิตาลี</a:t>
+              <a:t>บทที่ 2: แรงบันดาลใจจาก Italy</a:t>
             </a:r>
             <a:endParaRPr lang="en-US" sz="2175" dirty="0"/>
           </a:p>
@@ -7580,7 +7580,7 @@
                 <a:ea typeface="Sarabun" pitchFamily="34" charset="-122"/>
                 <a:cs typeface="Sarabun" pitchFamily="34" charset="-120"/>
               </a:rPr>
-              <a:t>การเดินทางไปมิลานเปลี่ยนประวัติศาสตร์กาแฟได้อย่างไร</a:t>
+              <a:t>ทริปไป Milan เปลี่ยนประวัติศาสตร์กาแฟได้อย่างไร</a:t>
             </a:r>
             <a:endParaRPr lang="en-US" sz="1200" dirty="0"/>
           </a:p>
@@ -7622,7 +7622,7 @@
                 <a:ea typeface="Sarabun" pitchFamily="34" charset="-122"/>
                 <a:cs typeface="Sarabun" pitchFamily="34" charset="-120"/>
               </a:rPr>
-              <a:t>ตอนที่ 2 · จุดเปลี่ยน</a:t>
+              <a:t>Part 2 · จุดเปลี่ยน (Turning Point)</a:t>
             </a:r>
             <a:endParaRPr lang="en-US" sz="900" dirty="0"/>
           </a:p>
@@ -7686,7 +7686,7 @@
                 <a:ea typeface="Sarabun" pitchFamily="34" charset="-122"/>
                 <a:cs typeface="Sarabun" pitchFamily="34" charset="-120"/>
               </a:rPr>
-              <a:t>1983 · การเดินทางไปมิลาน</a:t>
+              <a:t>1983 · ทริปไป Milan</a:t>
             </a:r>
             <a:endParaRPr lang="en-US" sz="900" dirty="0"/>
           </a:p>
@@ -7848,7 +7848,7 @@
                 <a:ea typeface="Pridi" pitchFamily="34" charset="-122"/>
                 <a:cs typeface="Pridi" pitchFamily="34" charset="-120"/>
               </a:rPr>
-              <a:t>การค้นพบ</a:t>
+              <a:t>The Discovery</a:t>
             </a:r>
             <a:endParaRPr lang="en-US" sz="1275" dirty="0"/>
           </a:p>
@@ -7890,7 +7890,7 @@
                 <a:ea typeface="Sarabun" pitchFamily="34" charset="-122"/>
                 <a:cs typeface="Sarabun" pitchFamily="34" charset="-120"/>
               </a:rPr>
-              <a:t>โฮเวิร์ด ชูลต์ซ ไปเยือนบาร์เอสเพรสโซในมิลาน และสังเกตว่าร้านเหล่านั้นไม่ได้แค่ขายเครื่องดื่ม แต่เป็น</a:t>
+              <a:t>Howard Schultz ไปเยือน Espresso Bar ใน Milan และสังเกตว่าร้านเหล่านั้นไม่ได้แค่ขายเครื่องดื่ม แต่เป็น </a:t>
             </a:r>
             <a:pPr algn="l" indent="0" marL="0">
               <a:lnSpc>
@@ -7907,7 +7907,7 @@
                 <a:ea typeface="Sarabun" pitchFamily="34" charset="-122"/>
                 <a:cs typeface="Sarabun" pitchFamily="34" charset="-120"/>
               </a:rPr>
-              <a:t>ห้องนั่งเล่นของชุมชน</a:t>
+              <a:t>Community Living Room</a:t>
             </a:r>
             <a:pPr algn="l" indent="0" marL="0">
               <a:lnSpc>
@@ -7924,7 +7924,7 @@
                 <a:ea typeface="Sarabun" pitchFamily="34" charset="-122"/>
                 <a:cs typeface="Sarabun" pitchFamily="34" charset="-120"/>
               </a:rPr>
-              <a:t>ที่มีชีวิตชีวา</a:t>
+              <a:t> ที่มีชีวิตชีวา</a:t>
             </a:r>
             <a:endParaRPr lang="en-US" sz="1013" dirty="0"/>
           </a:p>
@@ -7938,8 +7938,8 @@
         </p:nvSpPr>
         <p:spPr>
           <a:xfrm>
-            <a:off x="4295924" y="1676400"/>
-            <a:ext cx="556915" cy="228600"/>
+            <a:off x="4247629" y="1676400"/>
+            <a:ext cx="653504" cy="228600"/>
           </a:xfrm>
           <a:prstGeom prst="roundRect">
             <a:avLst>
@@ -7960,8 +7960,8 @@
         </p:nvSpPr>
         <p:spPr>
           <a:xfrm>
-            <a:off x="4295924" y="1676400"/>
-            <a:ext cx="601468" cy="228600"/>
+            <a:off x="4247629" y="1676400"/>
+            <a:ext cx="705785" cy="228600"/>
           </a:xfrm>
           <a:prstGeom prst="rect">
             <a:avLst/>
@@ -7988,7 +7988,7 @@
                 <a:ea typeface="Sarabun" pitchFamily="34" charset="-122"/>
                 <a:cs typeface="Sarabun" pitchFamily="34" charset="-120"/>
               </a:rPr>
-              <a:t>แนวคิด</a:t>
+              <a:t>The Idea</a:t>
             </a:r>
             <a:endParaRPr lang="en-US" sz="900" dirty="0"/>
           </a:p>
@@ -8064,7 +8064,7 @@
                 <a:ea typeface="Pridi" pitchFamily="34" charset="-122"/>
                 <a:cs typeface="Pridi" pitchFamily="34" charset="-120"/>
               </a:rPr>
-              <a:t>วิสัยทัศน์</a:t>
+              <a:t>The Vision</a:t>
             </a:r>
             <a:endParaRPr lang="en-US" sz="1275" dirty="0"/>
           </a:p>
@@ -8106,7 +8106,7 @@
                 <a:ea typeface="Sarabun" pitchFamily="34" charset="-122"/>
                 <a:cs typeface="Sarabun" pitchFamily="34" charset="-120"/>
               </a:rPr>
-              <a:t>อเมริกาต้องการวัฒนธรรมเอสเพรสโซแท้ ๆ ที่สร้างขึ้นจาก</a:t>
+              <a:t>อเมริกาต้องการวัฒนธรรม Espresso แท้ ๆ ที่สร้างจาก </a:t>
             </a:r>
             <a:pPr algn="l" indent="0" marL="0">
               <a:lnSpc>
@@ -8123,7 +8123,7 @@
                 <a:ea typeface="Sarabun" pitchFamily="34" charset="-122"/>
                 <a:cs typeface="Sarabun" pitchFamily="34" charset="-120"/>
               </a:rPr>
-              <a:t>การเชื่อมโยงระหว่างผู้คน ความรวดเร็ว และฝีมือ</a:t>
+              <a:t>Human Connection, Speed และ Craftsmanship</a:t>
             </a:r>
             <a:endParaRPr lang="en-US" sz="1013" dirty="0"/>
           </a:p>
@@ -8263,7 +8263,7 @@
                 <a:ea typeface="Pridi" pitchFamily="34" charset="-122"/>
                 <a:cs typeface="Pridi" pitchFamily="34" charset="-120"/>
               </a:rPr>
-              <a:t>การเข้าซื้อกิจการ</a:t>
+              <a:t>The Acquisition</a:t>
             </a:r>
             <a:endParaRPr lang="en-US" sz="1275" dirty="0"/>
           </a:p>
@@ -8305,7 +8305,7 @@
                 <a:ea typeface="Sarabun" pitchFamily="34" charset="-122"/>
                 <a:cs typeface="Sarabun" pitchFamily="34" charset="-120"/>
               </a:rPr>
-              <a:t>ชูลต์ซซื้อสตาร์บัคส์ในราคา </a:t>
+              <a:t>Schultz ซื้อ Starbucks ในราคา </a:t>
             </a:r>
             <a:pPr algn="l" indent="0" marL="0">
               <a:lnSpc>
@@ -8322,7 +8322,7 @@
                 <a:ea typeface="Sarabun" pitchFamily="34" charset="-122"/>
                 <a:cs typeface="Sarabun" pitchFamily="34" charset="-120"/>
               </a:rPr>
-              <a:t>3.8 ล้านดอลลาร์</a:t>
+              <a:t>$3.8M</a:t>
             </a:r>
             <a:pPr algn="l" indent="0" marL="0">
               <a:lnSpc>
@@ -8339,7 +8339,7 @@
                 <a:ea typeface="Sarabun" pitchFamily="34" charset="-122"/>
                 <a:cs typeface="Sarabun" pitchFamily="34" charset="-120"/>
               </a:rPr>
-              <a:t> และรวมแนวคิดร้าน Il Giornale ของเขาเข้าไป เปิดศักราชร้านกาแฟยุคใหม่</a:t>
+              <a:t> และรวม Concept ร้าน Il Giornale ของเขาเข้าไป เปิดศักราช Coffeehouse ยุคใหม่</a:t>
             </a:r>
             <a:endParaRPr lang="en-US" sz="1013" dirty="0"/>
           </a:p>
@@ -8423,7 +8423,7 @@
                 <a:ea typeface="Sarabun" pitchFamily="34" charset="-122"/>
                 <a:cs typeface="Sarabun" pitchFamily="34" charset="-120"/>
               </a:rPr>
-              <a:t>ชูลต์ซไม่ได้แค่อยากขายกาแฟ เขาอยากสร้าง</a:t>
+              <a:t>Schultz ไม่ได้แค่อยากขายกาแฟ เขาอยากสร้าง</a:t>
             </a:r>
             <a:pPr algn="l" indent="0" marL="0">
               <a:lnSpc>
@@ -8521,7 +8521,7 @@
                 <a:ea typeface="Sarabun" pitchFamily="34" charset="-122"/>
                 <a:cs typeface="Sarabun" pitchFamily="34" charset="-120"/>
               </a:rPr>
-              <a:t>Third Place · บ้านหลังที่สาม</a:t>
+              <a:t>The Third Place</a:t>
             </a:r>
             <a:endParaRPr lang="en-US" sz="900" dirty="0"/>
           </a:p>
@@ -8536,7 +8536,7 @@
         <p:spPr>
           <a:xfrm>
             <a:off x="609600" y="4667250"/>
-            <a:ext cx="1628254" cy="171450"/>
+            <a:ext cx="2310929" cy="171450"/>
           </a:xfrm>
           <a:prstGeom prst="rect">
             <a:avLst/>
@@ -8563,7 +8563,7 @@
                 <a:ea typeface="Sarabun" pitchFamily="34" charset="-122"/>
                 <a:cs typeface="Sarabun" pitchFamily="34" charset="-120"/>
               </a:rPr>
-              <a:t>สไลด์ 3 จาก 8 · ตอนที่ 2 · จุดเปลี่ยน</a:t>
+              <a:t>สไลด์ 3 จาก 8 · Part 2 · จุดเปลี่ยน (Turning Point)</a:t>
             </a:r>
             <a:endParaRPr lang="en-US" sz="900" dirty="0"/>
           </a:p>
@@ -8577,7 +8577,7 @@
         </p:nvSpPr>
         <p:spPr>
           <a:xfrm>
-            <a:off x="2428354" y="4724400"/>
+            <a:off x="3111029" y="4724400"/>
             <a:ext cx="57150" cy="57150"/>
           </a:xfrm>
           <a:prstGeom prst="roundRect">
@@ -8599,7 +8599,7 @@
         </p:nvSpPr>
         <p:spPr>
           <a:xfrm>
-            <a:off x="2533129" y="4724400"/>
+            <a:off x="3215804" y="4724400"/>
             <a:ext cx="57150" cy="57150"/>
           </a:xfrm>
           <a:prstGeom prst="roundRect">
@@ -8621,7 +8621,7 @@
         </p:nvSpPr>
         <p:spPr>
           <a:xfrm>
-            <a:off x="2637904" y="4724400"/>
+            <a:off x="3320579" y="4724400"/>
             <a:ext cx="171450" cy="57150"/>
           </a:xfrm>
           <a:prstGeom prst="roundRect">
@@ -8643,7 +8643,7 @@
         </p:nvSpPr>
         <p:spPr>
           <a:xfrm>
-            <a:off x="2856979" y="4724400"/>
+            <a:off x="3539654" y="4724400"/>
             <a:ext cx="57150" cy="57150"/>
           </a:xfrm>
           <a:prstGeom prst="roundRect">
@@ -8665,7 +8665,7 @@
         </p:nvSpPr>
         <p:spPr>
           <a:xfrm>
-            <a:off x="2961754" y="4724400"/>
+            <a:off x="3644429" y="4724400"/>
             <a:ext cx="57150" cy="57150"/>
           </a:xfrm>
           <a:prstGeom prst="roundRect">
@@ -8687,7 +8687,7 @@
         </p:nvSpPr>
         <p:spPr>
           <a:xfrm>
-            <a:off x="3066529" y="4724400"/>
+            <a:off x="3749204" y="4724400"/>
             <a:ext cx="57150" cy="57150"/>
           </a:xfrm>
           <a:prstGeom prst="roundRect">
@@ -8709,7 +8709,7 @@
         </p:nvSpPr>
         <p:spPr>
           <a:xfrm>
-            <a:off x="3171304" y="4724400"/>
+            <a:off x="3853979" y="4724400"/>
             <a:ext cx="57150" cy="57150"/>
           </a:xfrm>
           <a:prstGeom prst="roundRect">
@@ -8731,7 +8731,7 @@
         </p:nvSpPr>
         <p:spPr>
           <a:xfrm>
-            <a:off x="3276079" y="4724400"/>
+            <a:off x="3958754" y="4724400"/>
             <a:ext cx="57150" cy="57150"/>
           </a:xfrm>
           <a:prstGeom prst="roundRect">
@@ -9996,7 +9996,7 @@
                 <a:ea typeface="Pridi" pitchFamily="34" charset="-122"/>
                 <a:cs typeface="Pridi" pitchFamily="34" charset="-120"/>
               </a:rPr>
-              <a:t>บทที่ 3: กรอบแนวคิด "บ้านหลังที่สาม"</a:t>
+              <a:t>บทที่ 3: Framework "The Third Place"</a:t>
             </a:r>
             <a:endParaRPr lang="en-US" sz="2175" dirty="0"/>
           </a:p>
@@ -10038,7 +10038,7 @@
                 <a:ea typeface="Sarabun" pitchFamily="34" charset="-122"/>
                 <a:cs typeface="Sarabun" pitchFamily="34" charset="-120"/>
               </a:rPr>
-              <a:t>ปรัชญาหลักของแบรนด์</a:t>
+              <a:t>ปรัชญาหลักของแบรนด์ (Core Brand Philosophy)</a:t>
             </a:r>
             <a:endParaRPr lang="en-US" sz="1200" dirty="0"/>
           </a:p>
@@ -10080,7 +10080,7 @@
                 <a:ea typeface="Sarabun" pitchFamily="34" charset="-122"/>
                 <a:cs typeface="Sarabun" pitchFamily="34" charset="-120"/>
               </a:rPr>
-              <a:t>ตอนที่ 2 · การพัฒนาแนวคิด</a:t>
+              <a:t>Part 2 · การพัฒนา Concept</a:t>
             </a:r>
             <a:endParaRPr lang="en-US" sz="900" dirty="0"/>
           </a:p>
@@ -10144,7 +10144,7 @@
                 <a:ea typeface="Sarabun" pitchFamily="34" charset="-122"/>
                 <a:cs typeface="Sarabun" pitchFamily="34" charset="-120"/>
               </a:rPr>
-              <a:t>Third Place · บ้านหลังที่สาม</a:t>
+              <a:t>The Third Place</a:t>
             </a:r>
             <a:endParaRPr lang="en-US" sz="900" dirty="0"/>
           </a:p>
@@ -10242,7 +10242,7 @@
                 <a:ea typeface="Sarabun" pitchFamily="34" charset="-122"/>
                 <a:cs typeface="Sarabun" pitchFamily="34" charset="-120"/>
               </a:rPr>
-              <a:t>ที่หนึ่ง</a:t>
+              <a:t>1st Place</a:t>
             </a:r>
             <a:endParaRPr lang="en-US" sz="900" dirty="0"/>
           </a:p>
@@ -10368,7 +10368,7 @@
                 <a:ea typeface="Sarabun" pitchFamily="34" charset="-122"/>
                 <a:cs typeface="Sarabun" pitchFamily="34" charset="-120"/>
               </a:rPr>
-              <a:t>ที่สอง</a:t>
+              <a:t>2nd Place</a:t>
             </a:r>
             <a:endParaRPr lang="en-US" sz="900" dirty="0"/>
           </a:p>
@@ -10494,7 +10494,7 @@
                 <a:ea typeface="Sarabun" pitchFamily="34" charset="-122"/>
                 <a:cs typeface="Sarabun" pitchFamily="34" charset="-120"/>
               </a:rPr>
-              <a:t>ที่สาม</a:t>
+              <a:t>3rd Place</a:t>
             </a:r>
             <a:endParaRPr lang="en-US" sz="900" dirty="0"/>
           </a:p>
@@ -10536,7 +10536,7 @@
                 <a:ea typeface="Pridi" pitchFamily="34" charset="-122"/>
                 <a:cs typeface="Pridi" pitchFamily="34" charset="-120"/>
               </a:rPr>
-              <a:t>สตาร์บัคส์</a:t>
+              <a:t>Starbucks</a:t>
             </a:r>
             <a:endParaRPr lang="en-US" sz="1275" dirty="0"/>
           </a:p>
@@ -10578,7 +10578,7 @@
                 <a:ea typeface="Sarabun" pitchFamily="34" charset="-122"/>
                 <a:cs typeface="Sarabun" pitchFamily="34" charset="-120"/>
               </a:rPr>
-              <a:t>เสาหลักที่ 1 · บ้านหลังที่สาม</a:t>
+              <a:t>Pillar 1 · The Third Place</a:t>
             </a:r>
             <a:endParaRPr lang="en-US" sz="900" dirty="0"/>
           </a:p>
@@ -10620,7 +10620,7 @@
                 <a:ea typeface="Sarabun" pitchFamily="34" charset="-122"/>
                 <a:cs typeface="Sarabun" pitchFamily="34" charset="-120"/>
               </a:rPr>
-              <a:t>ที่พักพิงอันอบอุ่น ปราศจากความกดดัน ระหว่างบ้านกับที่ทำงาน</a:t>
+              <a:t>ที่พักพิงอันอบอุ่น ไร้ความกดดัน ระหว่างบ้านกับที่ทำงาน</a:t>
             </a:r>
             <a:endParaRPr lang="en-US" sz="1013" dirty="0"/>
           </a:p>
@@ -10696,7 +10696,7 @@
                 <a:ea typeface="Sarabun" pitchFamily="34" charset="-122"/>
                 <a:cs typeface="Sarabun" pitchFamily="34" charset="-120"/>
               </a:rPr>
-              <a:t>เสาหลักที่ 2 · ความผูกพันทางอารมณ์</a:t>
+              <a:t>Pillar 2 · Emotional Connection</a:t>
             </a:r>
             <a:endParaRPr lang="en-US" sz="900" dirty="0"/>
           </a:p>
@@ -10780,7 +10780,7 @@
                 <a:ea typeface="Sarabun" pitchFamily="34" charset="-122"/>
                 <a:cs typeface="Sarabun" pitchFamily="34" charset="-120"/>
               </a:rPr>
-              <a:t>โฮเวิร์ด ชูลต์ซ</a:t>
+              <a:t>Howard Schultz</a:t>
             </a:r>
             <a:endParaRPr lang="en-US" sz="900" dirty="0"/>
           </a:p>
@@ -10856,7 +10856,7 @@
                 <a:ea typeface="Sarabun" pitchFamily="34" charset="-122"/>
                 <a:cs typeface="Sarabun" pitchFamily="34" charset="-120"/>
               </a:rPr>
-              <a:t>เสาหลักที่ 3 · บรรยากาศคือผลิตภัณฑ์</a:t>
+              <a:t>Pillar 3 · Atmosphere คือ Product</a:t>
             </a:r>
             <a:endParaRPr lang="en-US" sz="900" dirty="0"/>
           </a:p>
@@ -10935,7 +10935,7 @@
         <p:spPr>
           <a:xfrm>
             <a:off x="5724599" y="2909888"/>
-            <a:ext cx="656630" cy="262830"/>
+            <a:ext cx="790649" cy="262830"/>
           </a:xfrm>
           <a:prstGeom prst="roundRect">
             <a:avLst>
@@ -10957,7 +10957,7 @@
         <p:spPr>
           <a:xfrm>
             <a:off x="5724599" y="2909888"/>
-            <a:ext cx="709160" cy="262830"/>
+            <a:ext cx="853901" cy="262830"/>
           </a:xfrm>
           <a:prstGeom prst="rect">
             <a:avLst/>
@@ -10984,7 +10984,7 @@
                 <a:ea typeface="Sarabun" pitchFamily="34" charset="-122"/>
                 <a:cs typeface="Sarabun" pitchFamily="34" charset="-120"/>
               </a:rPr>
-              <a:t>พื้นผิวไม้</a:t>
+              <a:t>Texture ไม้</a:t>
             </a:r>
             <a:endParaRPr lang="en-US" sz="1050" dirty="0"/>
           </a:p>
@@ -10998,8 +10998,8 @@
         </p:nvSpPr>
         <p:spPr>
           <a:xfrm>
-            <a:off x="6438379" y="2909888"/>
-            <a:ext cx="964927" cy="262830"/>
+            <a:off x="6572399" y="2909888"/>
+            <a:ext cx="1020217" cy="262830"/>
           </a:xfrm>
           <a:prstGeom prst="roundRect">
             <a:avLst>
@@ -11020,8 +11020,8 @@
         </p:nvSpPr>
         <p:spPr>
           <a:xfrm>
-            <a:off x="6438379" y="2909888"/>
-            <a:ext cx="1042121" cy="262830"/>
+            <a:off x="6572399" y="2909888"/>
+            <a:ext cx="1101834" cy="262830"/>
           </a:xfrm>
           <a:prstGeom prst="rect">
             <a:avLst/>
@@ -11048,7 +11048,7 @@
                 <a:ea typeface="Sarabun" pitchFamily="34" charset="-122"/>
                 <a:cs typeface="Sarabun" pitchFamily="34" charset="-120"/>
               </a:rPr>
-              <a:t>ดนตรีอะคูสติก</a:t>
+              <a:t>ดนตรี Acoustic</a:t>
             </a:r>
             <a:endParaRPr lang="en-US" sz="1050" dirty="0"/>
           </a:p>
@@ -11218,7 +11218,7 @@
                 <a:ea typeface="Sarabun" pitchFamily="34" charset="-122"/>
                 <a:cs typeface="Sarabun" pitchFamily="34" charset="-120"/>
               </a:rPr>
-              <a:t>เมื่อเข้าใจแนวคิดเชิงกลยุทธ์ของบ้านหลังที่สามแล้ว สตาร์บัคส์</a:t>
+              <a:t>เมื่อเข้าใจ Concept เชิงกลยุทธ์ของ Third Place แล้ว Starbucks </a:t>
             </a:r>
             <a:pPr algn="l" indent="0" marL="0">
               <a:lnSpc>
@@ -11235,7 +11235,7 @@
                 <a:ea typeface="Sarabun" pitchFamily="34" charset="-122"/>
                 <a:cs typeface="Sarabun" pitchFamily="34" charset="-120"/>
               </a:rPr>
-              <a:t>ขยายประสบการณ์แบบมนุษย์นี้</a:t>
+              <a:t>ขยาย Human Experience นี้</a:t>
             </a:r>
             <a:pPr algn="l" indent="0" marL="0">
               <a:lnSpc>
@@ -11316,7 +11316,7 @@
                 <a:ea typeface="Sarabun" pitchFamily="34" charset="-122"/>
                 <a:cs typeface="Sarabun" pitchFamily="34" charset="-120"/>
               </a:rPr>
-              <a:t>ประสบการณ์แบบมนุษย์ ในสเกลใหญ่</a:t>
+              <a:t>ขยาย Human Experience สู่ทุกสาขา</a:t>
             </a:r>
             <a:endParaRPr lang="en-US" sz="900" dirty="0"/>
           </a:p>
@@ -11331,7 +11331,7 @@
         <p:spPr>
           <a:xfrm>
             <a:off x="609600" y="4667250"/>
-            <a:ext cx="1998464" cy="171450"/>
+            <a:ext cx="2023616" cy="171450"/>
           </a:xfrm>
           <a:prstGeom prst="rect">
             <a:avLst/>
@@ -11358,7 +11358,7 @@
                 <a:ea typeface="Sarabun" pitchFamily="34" charset="-122"/>
                 <a:cs typeface="Sarabun" pitchFamily="34" charset="-120"/>
               </a:rPr>
-              <a:t>สไลด์ 4 จาก 8 · ตอนที่ 2 · การพัฒนาแนวคิด</a:t>
+              <a:t>สไลด์ 4 จาก 8 · Part 2 · การพัฒนา Concept</a:t>
             </a:r>
             <a:endParaRPr lang="en-US" sz="900" dirty="0"/>
           </a:p>
@@ -11372,7 +11372,7 @@
         </p:nvSpPr>
         <p:spPr>
           <a:xfrm>
-            <a:off x="2798564" y="4724400"/>
+            <a:off x="2823716" y="4724400"/>
             <a:ext cx="57150" cy="57150"/>
           </a:xfrm>
           <a:prstGeom prst="roundRect">
@@ -11394,7 +11394,7 @@
         </p:nvSpPr>
         <p:spPr>
           <a:xfrm>
-            <a:off x="2903339" y="4724400"/>
+            <a:off x="2928491" y="4724400"/>
             <a:ext cx="57150" cy="57150"/>
           </a:xfrm>
           <a:prstGeom prst="roundRect">
@@ -11416,7 +11416,7 @@
         </p:nvSpPr>
         <p:spPr>
           <a:xfrm>
-            <a:off x="3008114" y="4724400"/>
+            <a:off x="3033266" y="4724400"/>
             <a:ext cx="57150" cy="57150"/>
           </a:xfrm>
           <a:prstGeom prst="roundRect">
@@ -11438,7 +11438,7 @@
         </p:nvSpPr>
         <p:spPr>
           <a:xfrm>
-            <a:off x="3112889" y="4724400"/>
+            <a:off x="3138041" y="4724400"/>
             <a:ext cx="171450" cy="57150"/>
           </a:xfrm>
           <a:prstGeom prst="roundRect">
@@ -11460,7 +11460,7 @@
         </p:nvSpPr>
         <p:spPr>
           <a:xfrm>
-            <a:off x="3331964" y="4724400"/>
+            <a:off x="3357116" y="4724400"/>
             <a:ext cx="57150" cy="57150"/>
           </a:xfrm>
           <a:prstGeom prst="roundRect">
@@ -11482,7 +11482,7 @@
         </p:nvSpPr>
         <p:spPr>
           <a:xfrm>
-            <a:off x="3436739" y="4724400"/>
+            <a:off x="3461891" y="4724400"/>
             <a:ext cx="57150" cy="57150"/>
           </a:xfrm>
           <a:prstGeom prst="roundRect">
@@ -11504,7 +11504,7 @@
         </p:nvSpPr>
         <p:spPr>
           <a:xfrm>
-            <a:off x="3541514" y="4724400"/>
+            <a:off x="3566666" y="4724400"/>
             <a:ext cx="57150" cy="57150"/>
           </a:xfrm>
           <a:prstGeom prst="roundRect">
@@ -11526,7 +11526,7 @@
         </p:nvSpPr>
         <p:spPr>
           <a:xfrm>
-            <a:off x="3646289" y="4724400"/>
+            <a:off x="3671441" y="4724400"/>
             <a:ext cx="57150" cy="57150"/>
           </a:xfrm>
           <a:prstGeom prst="roundRect">
@@ -13567,7 +13567,7 @@
         <p:spPr>
           <a:xfrm>
             <a:off x="609600" y="819150"/>
-            <a:ext cx="6686550" cy="359048"/>
+            <a:ext cx="8023860" cy="359048"/>
           </a:xfrm>
           <a:prstGeom prst="rect">
             <a:avLst/>
@@ -13594,7 +13594,7 @@
                 <a:ea typeface="Pridi" pitchFamily="34" charset="-122"/>
                 <a:cs typeface="Pridi" pitchFamily="34" charset="-120"/>
               </a:rPr>
-              <a:t>บทที่ 4: การเล่าเรื่องผ่านจุดสัมผัส</a:t>
+              <a:t>บทที่ 4: Storytelling ผ่าน Touchpoints</a:t>
             </a:r>
             <a:endParaRPr lang="en-US" sz="2175" dirty="0"/>
           </a:p>
@@ -13636,7 +13636,7 @@
                 <a:ea typeface="Sarabun" pitchFamily="34" charset="-122"/>
                 <a:cs typeface="Sarabun" pitchFamily="34" charset="-120"/>
               </a:rPr>
-              <a:t>เปลี่ยนกิจวัตรประจำวันให้เป็นความภักดีต่อแบรนด์</a:t>
+              <a:t>เปลี่ยน Ritual ประจำวันให้เป็น Brand Loyalty</a:t>
             </a:r>
             <a:endParaRPr lang="en-US" sz="1200" dirty="0"/>
           </a:p>
@@ -13678,7 +13678,7 @@
                 <a:ea typeface="Sarabun" pitchFamily="34" charset="-122"/>
                 <a:cs typeface="Sarabun" pitchFamily="34" charset="-120"/>
               </a:rPr>
-              <a:t>ตอนที่ 3 · การนำประสบการณ์ไปปฏิบัติจริง</a:t>
+              <a:t>Part 3 · การนำ Experience ไปปฏิบัติจริง</a:t>
             </a:r>
             <a:endParaRPr lang="en-US" sz="900" dirty="0"/>
           </a:p>
@@ -13742,7 +13742,7 @@
                 <a:ea typeface="Sarabun" pitchFamily="34" charset="-122"/>
                 <a:cs typeface="Sarabun" pitchFamily="34" charset="-120"/>
               </a:rPr>
-              <a:t>ประสบการณ์แบบมนุษย์ ในสเกลใหญ่</a:t>
+              <a:t>ขยาย Human Experience สู่ทุกสาขา</a:t>
             </a:r>
             <a:endParaRPr lang="en-US" sz="900" dirty="0"/>
           </a:p>
@@ -13837,7 +13837,7 @@
         <p:spPr>
           <a:xfrm>
             <a:off x="1147763" y="1900238"/>
-            <a:ext cx="634579" cy="171450"/>
+            <a:ext cx="729252" cy="171450"/>
           </a:xfrm>
           <a:prstGeom prst="rect">
             <a:avLst/>
@@ -13864,7 +13864,7 @@
                 <a:ea typeface="Sarabun" pitchFamily="34" charset="-122"/>
                 <a:cs typeface="Sarabun" pitchFamily="34" charset="-120"/>
               </a:rPr>
-              <a:t>จุดสัมผัสที่ 1</a:t>
+              <a:t>Touchpoint 1</a:t>
             </a:r>
             <a:endParaRPr lang="en-US" sz="900" dirty="0"/>
           </a:p>
@@ -13906,7 +13906,7 @@
                 <a:ea typeface="Pridi" pitchFamily="34" charset="-122"/>
                 <a:cs typeface="Pridi" pitchFamily="34" charset="-120"/>
               </a:rPr>
-              <a:t>ความเป็นส่วนตัวและการเชื่อมโยง</a:t>
+              <a:t>Personalization &amp; Connection</a:t>
             </a:r>
             <a:endParaRPr lang="en-US" sz="1275" dirty="0"/>
           </a:p>
@@ -13921,7 +13921,7 @@
         <p:spPr>
           <a:xfrm>
             <a:off x="766763" y="2498378"/>
-            <a:ext cx="2342769" cy="398562"/>
+            <a:ext cx="2342769" cy="597843"/>
           </a:xfrm>
           <a:prstGeom prst="rect">
             <a:avLst/>
@@ -13948,7 +13948,7 @@
                 <a:ea typeface="Sarabun" pitchFamily="34" charset="-122"/>
                 <a:cs typeface="Sarabun" pitchFamily="34" charset="-120"/>
               </a:rPr>
-              <a:t>เขียนชื่อลูกค้าบนแก้ว บาริสต้าสบตาขณะให้บริการ และเครื่องดื่มที่ปรับแต่งได้ตามใจ</a:t>
+              <a:t>เขียนชื่อลูกค้าบนแก้ว Barista สบตาขณะให้บริการ และเครื่องดื่ม Handcrafted ที่ Customize ได้</a:t>
             </a:r>
             <a:endParaRPr lang="en-US" sz="1013" dirty="0"/>
           </a:p>
@@ -14043,7 +14043,7 @@
         <p:spPr>
           <a:xfrm>
             <a:off x="3829050" y="1900238"/>
-            <a:ext cx="634579" cy="171450"/>
+            <a:ext cx="729252" cy="171450"/>
           </a:xfrm>
           <a:prstGeom prst="rect">
             <a:avLst/>
@@ -14070,7 +14070,7 @@
                 <a:ea typeface="Sarabun" pitchFamily="34" charset="-122"/>
                 <a:cs typeface="Sarabun" pitchFamily="34" charset="-120"/>
               </a:rPr>
-              <a:t>จุดสัมผัสที่ 2</a:t>
+              <a:t>Touchpoint 2</a:t>
             </a:r>
             <a:endParaRPr lang="en-US" sz="900" dirty="0"/>
           </a:p>
@@ -14112,7 +14112,7 @@
                 <a:ea typeface="Pridi" pitchFamily="34" charset="-122"/>
                 <a:cs typeface="Pridi" pitchFamily="34" charset="-120"/>
               </a:rPr>
-              <a:t>ความสม่ำเสมอทางประสาทสัมผัส</a:t>
+              <a:t>Sensory Consistency</a:t>
             </a:r>
             <a:endParaRPr lang="en-US" sz="1275" dirty="0"/>
           </a:p>
@@ -14127,7 +14127,7 @@
         <p:spPr>
           <a:xfrm>
             <a:off x="3448050" y="2498378"/>
-            <a:ext cx="2342769" cy="597843"/>
+            <a:ext cx="2342769" cy="398562"/>
           </a:xfrm>
           <a:prstGeom prst="rect">
             <a:avLst/>
@@ -14154,7 +14154,7 @@
                 <a:ea typeface="Sarabun" pitchFamily="34" charset="-122"/>
                 <a:cs typeface="Sarabun" pitchFamily="34" charset="-120"/>
               </a:rPr>
-              <a:t>การออกแบบบรรยากาศ กลิ่นเอกลักษณ์ และเพลย์ลิสต์ที่คัดสรร เหมือนกันทุกสาขาทั่วโลก</a:t>
+              <a:t>Ambient Design, กลิ่น Signature และ Playlist ที่คัดสรร เหมือนกันทุกสาขาทั่วโลก</a:t>
             </a:r>
             <a:endParaRPr lang="en-US" sz="1013" dirty="0"/>
           </a:p>
@@ -14249,7 +14249,7 @@
         <p:spPr>
           <a:xfrm>
             <a:off x="6510337" y="1900238"/>
-            <a:ext cx="634579" cy="171450"/>
+            <a:ext cx="729252" cy="171450"/>
           </a:xfrm>
           <a:prstGeom prst="rect">
             <a:avLst/>
@@ -14276,7 +14276,7 @@
                 <a:ea typeface="Sarabun" pitchFamily="34" charset="-122"/>
                 <a:cs typeface="Sarabun" pitchFamily="34" charset="-120"/>
               </a:rPr>
-              <a:t>จุดสัมผัสที่ 3</a:t>
+              <a:t>Touchpoint 3</a:t>
             </a:r>
             <a:endParaRPr lang="en-US" sz="900" dirty="0"/>
           </a:p>
@@ -14318,7 +14318,7 @@
                 <a:ea typeface="Pridi" pitchFamily="34" charset="-122"/>
                 <a:cs typeface="Pridi" pitchFamily="34" charset="-120"/>
               </a:rPr>
-              <a:t>ปรับให้เข้ากับชุมชน</a:t>
+              <a:t>Community Customization</a:t>
             </a:r>
             <a:endParaRPr lang="en-US" sz="1275" dirty="0"/>
           </a:p>
@@ -14333,7 +14333,7 @@
         <p:spPr>
           <a:xfrm>
             <a:off x="6129338" y="2498378"/>
-            <a:ext cx="2337816" cy="398562"/>
+            <a:ext cx="2337816" cy="597843"/>
           </a:xfrm>
           <a:prstGeom prst="rect">
             <a:avLst/>
@@ -14360,7 +14360,7 @@
                 <a:ea typeface="Sarabun" pitchFamily="34" charset="-122"/>
                 <a:cs typeface="Sarabun" pitchFamily="34" charset="-120"/>
               </a:rPr>
-              <a:t>สถาปัตยกรรมร้านที่สะท้อนมรดกของย่านนั้น ๆ โดยยังคงคุณค่าหลักของแบรนด์</a:t>
+              <a:t>สถาปัตยกรรมร้านที่สะท้อน Heritage ของย่านนั้น ๆ โดยยังคง Core Values ของแบรนด์</a:t>
             </a:r>
             <a:endParaRPr lang="en-US" sz="1013" dirty="0"/>
           </a:p>
@@ -14444,7 +14444,7 @@
                 <a:ea typeface="Sarabun" pitchFamily="34" charset="-122"/>
                 <a:cs typeface="Sarabun" pitchFamily="34" charset="-120"/>
               </a:rPr>
-              <a:t>เมื่อไลฟ์สไตล์ของลูกค้าเปลี่ยนไป สตาร์บัคส์ต้องพา "บ้านหลังที่สาม" เข้าสู่</a:t>
+              <a:t>เมื่อ Lifestyle ของลูกค้าเปลี่ยนไป Starbucks ต้องพา "The Third Place" เข้าสู่</a:t>
             </a:r>
             <a:pPr algn="l" indent="0" marL="0">
               <a:lnSpc>
@@ -14461,7 +14461,7 @@
                 <a:ea typeface="Sarabun" pitchFamily="34" charset="-122"/>
                 <a:cs typeface="Sarabun" pitchFamily="34" charset="-120"/>
               </a:rPr>
-              <a:t>ยุคดิจิทัล</a:t>
+              <a:t>ยุค Digital</a:t>
             </a:r>
             <a:pPr algn="l" indent="0" marL="0">
               <a:lnSpc>
@@ -14542,7 +14542,7 @@
                 <a:ea typeface="Sarabun" pitchFamily="34" charset="-122"/>
                 <a:cs typeface="Sarabun" pitchFamily="34" charset="-120"/>
               </a:rPr>
-              <a:t>บ้านหลังที่สามแบบดิจิทัล</a:t>
+              <a:t>Digital Third Place</a:t>
             </a:r>
             <a:endParaRPr lang="en-US" sz="900" dirty="0"/>
           </a:p>
@@ -14557,7 +14557,7 @@
         <p:spPr>
           <a:xfrm>
             <a:off x="609600" y="4667250"/>
-            <a:ext cx="2668042" cy="171450"/>
+            <a:ext cx="2580680" cy="171450"/>
           </a:xfrm>
           <a:prstGeom prst="rect">
             <a:avLst/>
@@ -14584,7 +14584,7 @@
                 <a:ea typeface="Sarabun" pitchFamily="34" charset="-122"/>
                 <a:cs typeface="Sarabun" pitchFamily="34" charset="-120"/>
               </a:rPr>
-              <a:t>สไลด์ 5 จาก 8 · ตอนที่ 3 · การนำประสบการณ์ไปปฏิบัติจริง</a:t>
+              <a:t>สไลด์ 5 จาก 8 · Part 3 · การนำ Experience ไปปฏิบัติจริง</a:t>
             </a:r>
             <a:endParaRPr lang="en-US" sz="900" dirty="0"/>
           </a:p>
@@ -14598,7 +14598,7 @@
         </p:nvSpPr>
         <p:spPr>
           <a:xfrm>
-            <a:off x="3468142" y="4724400"/>
+            <a:off x="3380780" y="4724400"/>
             <a:ext cx="57150" cy="57150"/>
           </a:xfrm>
           <a:prstGeom prst="roundRect">
@@ -14620,7 +14620,7 @@
         </p:nvSpPr>
         <p:spPr>
           <a:xfrm>
-            <a:off x="3572917" y="4724400"/>
+            <a:off x="3485555" y="4724400"/>
             <a:ext cx="57150" cy="57150"/>
           </a:xfrm>
           <a:prstGeom prst="roundRect">
@@ -14642,7 +14642,7 @@
         </p:nvSpPr>
         <p:spPr>
           <a:xfrm>
-            <a:off x="3677692" y="4724400"/>
+            <a:off x="3590330" y="4724400"/>
             <a:ext cx="57150" cy="57150"/>
           </a:xfrm>
           <a:prstGeom prst="roundRect">
@@ -14664,7 +14664,7 @@
         </p:nvSpPr>
         <p:spPr>
           <a:xfrm>
-            <a:off x="3782467" y="4724400"/>
+            <a:off x="3695105" y="4724400"/>
             <a:ext cx="57150" cy="57150"/>
           </a:xfrm>
           <a:prstGeom prst="roundRect">
@@ -14686,7 +14686,7 @@
         </p:nvSpPr>
         <p:spPr>
           <a:xfrm>
-            <a:off x="3887242" y="4724400"/>
+            <a:off x="3799880" y="4724400"/>
             <a:ext cx="171450" cy="57150"/>
           </a:xfrm>
           <a:prstGeom prst="roundRect">
@@ -14708,7 +14708,7 @@
         </p:nvSpPr>
         <p:spPr>
           <a:xfrm>
-            <a:off x="4106317" y="4724400"/>
+            <a:off x="4018955" y="4724400"/>
             <a:ext cx="57150" cy="57150"/>
           </a:xfrm>
           <a:prstGeom prst="roundRect">
@@ -14730,7 +14730,7 @@
         </p:nvSpPr>
         <p:spPr>
           <a:xfrm>
-            <a:off x="4211092" y="4724400"/>
+            <a:off x="4123730" y="4724400"/>
             <a:ext cx="57150" cy="57150"/>
           </a:xfrm>
           <a:prstGeom prst="roundRect">
@@ -14752,7 +14752,7 @@
         </p:nvSpPr>
         <p:spPr>
           <a:xfrm>
-            <a:off x="4315867" y="4724400"/>
+            <a:off x="4228505" y="4724400"/>
             <a:ext cx="57150" cy="57150"/>
           </a:xfrm>
           <a:prstGeom prst="roundRect">
@@ -16191,7 +16191,7 @@
                 <a:ea typeface="Pridi" pitchFamily="34" charset="-122"/>
                 <a:cs typeface="Pridi" pitchFamily="34" charset="-120"/>
               </a:rPr>
-              <a:t>บทที่ 5: "บ้านหลังที่สาม" แบบดิจิทัล</a:t>
+              <a:t>บทที่ 5: Digital "Third Place"</a:t>
             </a:r>
             <a:endParaRPr lang="en-US" sz="2175" dirty="0"/>
           </a:p>
@@ -16233,7 +16233,7 @@
                 <a:ea typeface="Sarabun" pitchFamily="34" charset="-122"/>
                 <a:cs typeface="Sarabun" pitchFamily="34" charset="-120"/>
               </a:rPr>
-              <a:t>ผสานการต้อนรับที่หน้าร้านเข้ากับความสะดวกแบบดิจิทัล</a:t>
+              <a:t>ผสาน Physical Hospitality เข้ากับ Digital Convenience</a:t>
             </a:r>
             <a:endParaRPr lang="en-US" sz="1200" dirty="0"/>
           </a:p>
@@ -16275,7 +16275,7 @@
                 <a:ea typeface="Sarabun" pitchFamily="34" charset="-122"/>
                 <a:cs typeface="Sarabun" pitchFamily="34" charset="-120"/>
               </a:rPr>
-              <a:t>ตอนที่ 3 · วิวัฒนาการยุคใหม่</a:t>
+              <a:t>Part 3 · วิวัฒนาการยุคใหม่</a:t>
             </a:r>
             <a:endParaRPr lang="en-US" sz="900" dirty="0"/>
           </a:p>
@@ -16339,7 +16339,7 @@
                 <a:ea typeface="Sarabun" pitchFamily="34" charset="-122"/>
                 <a:cs typeface="Sarabun" pitchFamily="34" charset="-120"/>
               </a:rPr>
-              <a:t>บ้านหลังที่สามแบบดิจิทัล</a:t>
+              <a:t>Digital Third Place</a:t>
             </a:r>
             <a:endParaRPr lang="en-US" sz="900" dirty="0"/>
           </a:p>
@@ -16461,7 +16461,7 @@
                 <a:ea typeface="Pridi" pitchFamily="34" charset="-122"/>
                 <a:cs typeface="Pridi" pitchFamily="34" charset="-120"/>
               </a:rPr>
-              <a:t>แอป Starbucks Rewards</a:t>
+              <a:t>Starbucks Rewards App</a:t>
             </a:r>
             <a:endParaRPr lang="en-US" sz="1200" dirty="0"/>
           </a:p>
@@ -16503,7 +16503,7 @@
                 <a:ea typeface="Sarabun" pitchFamily="34" charset="-122"/>
                 <a:cs typeface="Sarabun" pitchFamily="34" charset="-120"/>
               </a:rPr>
-              <a:t>โปรแกรมสะสมคะแนนแบบเกม มีสมาชิกใช้งาน</a:t>
+              <a:t>Loyalty Program แบบ Gamified มี </a:t>
             </a:r>
             <a:pPr algn="l" indent="0" marL="0">
               <a:lnSpc>
@@ -16520,7 +16520,7 @@
                 <a:ea typeface="Sarabun" pitchFamily="34" charset="-122"/>
                 <a:cs typeface="Sarabun" pitchFamily="34" charset="-120"/>
               </a:rPr>
-              <a:t>กว่า 30 ล้านคน</a:t>
+              <a:t>Active Member กว่า 30 ล้านคน</a:t>
             </a:r>
             <a:endParaRPr lang="en-US" sz="975" dirty="0"/>
           </a:p>
@@ -16684,7 +16684,7 @@
                 <a:ea typeface="Sarabun" pitchFamily="34" charset="-122"/>
                 <a:cs typeface="Sarabun" pitchFamily="34" charset="-120"/>
               </a:rPr>
-              <a:t>สั่งและจ่ายล่วงหน้า สะดวก ไร้รอยต่อ</a:t>
+              <a:t>สั่งและจ่ายล่วงหน้า สะดวก ไร้ Friction</a:t>
             </a:r>
             <a:endParaRPr lang="en-US" sz="975" dirty="0"/>
           </a:p>
@@ -16806,7 +16806,7 @@
                 <a:ea typeface="Pridi" pitchFamily="34" charset="-122"/>
                 <a:cs typeface="Pridi" pitchFamily="34" charset="-120"/>
               </a:rPr>
-              <a:t>การปรับแต่งเฉพาะบุคคลแบบดิจิทัล</a:t>
+              <a:t>Digital Personalization</a:t>
             </a:r>
             <a:endParaRPr lang="en-US" sz="1200" dirty="0"/>
           </a:p>
@@ -16848,7 +16848,7 @@
                 <a:ea typeface="Sarabun" pitchFamily="34" charset="-122"/>
                 <a:cs typeface="Sarabun" pitchFamily="34" charset="-120"/>
               </a:rPr>
-              <a:t>ระบบแนะนำด้วย AI ที่ปรับข้อเสนอให้ตรงรสนิยมของแต่ละคน</a:t>
+              <a:t>Recommendation Engine ที่ขับเคลื่อนด้วย AI ปรับข้อเสนอให้ตรงรสนิยมของแต่ละคน</a:t>
             </a:r>
             <a:endParaRPr lang="en-US" sz="975" dirty="0"/>
           </a:p>
@@ -16970,7 +16970,7 @@
                 <a:ea typeface="Pridi" pitchFamily="34" charset="-122"/>
                 <a:cs typeface="Pridi" pitchFamily="34" charset="-120"/>
               </a:rPr>
-              <a:t>ออมนิแชนแนลยุคใหม่</a:t>
+              <a:t>Modern Omnichannel</a:t>
             </a:r>
             <a:endParaRPr lang="en-US" sz="1200" dirty="0"/>
           </a:p>
@@ -17012,7 +17012,7 @@
                 <a:ea typeface="Sarabun" pitchFamily="34" charset="-122"/>
                 <a:cs typeface="Sarabun" pitchFamily="34" charset="-120"/>
               </a:rPr>
-              <a:t>รักษาการเชื่อมโยงกับผู้คนไว้ ทั้งผ่านไดรฟ์ทรูและบริการเดลิเวอรี</a:t>
+              <a:t>รักษา Human Connection ไว้ ทั้งผ่าน Drive-thru และ Delivery</a:t>
             </a:r>
             <a:endParaRPr lang="en-US" sz="975" dirty="0"/>
           </a:p>
@@ -17142,7 +17142,7 @@
                 <a:ea typeface="Sarabun" pitchFamily="34" charset="-122"/>
                 <a:cs typeface="Sarabun" pitchFamily="34" charset="-120"/>
               </a:rPr>
-              <a:t>เมื่อเชี่ยวชาญทั้งประสบการณ์หน้าร้านและนวัตกรรมดิจิทัลแล้ว </a:t>
+              <a:t>เมื่อเชี่ยวชาญทั้ง Physical Experience และ Digital Innovation แล้ว </a:t>
             </a:r>
             <a:pPr algn="l" indent="0" marL="0">
               <a:lnSpc>
@@ -17159,7 +17159,7 @@
                 <a:ea typeface="Sarabun" pitchFamily="34" charset="-122"/>
                 <a:cs typeface="Sarabun" pitchFamily="34" charset="-120"/>
               </a:rPr>
-              <a:t>ผลกระทบทางธุรกิจระดับโลก</a:t>
+              <a:t>Global Business Impact</a:t>
             </a:r>
             <a:pPr algn="l" indent="0" marL="0">
               <a:lnSpc>
@@ -17176,7 +17176,7 @@
                 <a:ea typeface="Sarabun" pitchFamily="34" charset="-122"/>
                 <a:cs typeface="Sarabun" pitchFamily="34" charset="-120"/>
               </a:rPr>
-              <a:t>เป็นอย่างไร?</a:t>
+              <a:t> เป็นอย่างไร?</a:t>
             </a:r>
             <a:endParaRPr lang="en-US" sz="1013" dirty="0"/>
           </a:p>
@@ -17240,7 +17240,7 @@
                 <a:ea typeface="Sarabun" pitchFamily="34" charset="-122"/>
                 <a:cs typeface="Sarabun" pitchFamily="34" charset="-120"/>
               </a:rPr>
-              <a:t>การขยายสู่ระดับโลก</a:t>
+              <a:t>Global Reach &amp; Scale</a:t>
             </a:r>
             <a:endParaRPr lang="en-US" sz="900" dirty="0"/>
           </a:p>
@@ -17255,7 +17255,7 @@
         <p:spPr>
           <a:xfrm>
             <a:off x="609600" y="4667250"/>
-            <a:ext cx="2019449" cy="171450"/>
+            <a:ext cx="1939007" cy="171450"/>
           </a:xfrm>
           <a:prstGeom prst="rect">
             <a:avLst/>
@@ -17282,7 +17282,7 @@
                 <a:ea typeface="Sarabun" pitchFamily="34" charset="-122"/>
                 <a:cs typeface="Sarabun" pitchFamily="34" charset="-120"/>
               </a:rPr>
-              <a:t>สไลด์ 6 จาก 8 · ตอนที่ 3 · วิวัฒนาการยุคใหม่</a:t>
+              <a:t>สไลด์ 6 จาก 8 · Part 3 · วิวัฒนาการยุคใหม่</a:t>
             </a:r>
             <a:endParaRPr lang="en-US" sz="900" dirty="0"/>
           </a:p>
@@ -17296,7 +17296,7 @@
         </p:nvSpPr>
         <p:spPr>
           <a:xfrm>
-            <a:off x="2819549" y="4724400"/>
+            <a:off x="2739107" y="4724400"/>
             <a:ext cx="57150" cy="57150"/>
           </a:xfrm>
           <a:prstGeom prst="roundRect">
@@ -17318,7 +17318,7 @@
         </p:nvSpPr>
         <p:spPr>
           <a:xfrm>
-            <a:off x="2924324" y="4724400"/>
+            <a:off x="2843882" y="4724400"/>
             <a:ext cx="57150" cy="57150"/>
           </a:xfrm>
           <a:prstGeom prst="roundRect">
@@ -17340,7 +17340,7 @@
         </p:nvSpPr>
         <p:spPr>
           <a:xfrm>
-            <a:off x="3029099" y="4724400"/>
+            <a:off x="2948657" y="4724400"/>
             <a:ext cx="57150" cy="57150"/>
           </a:xfrm>
           <a:prstGeom prst="roundRect">
@@ -17362,7 +17362,7 @@
         </p:nvSpPr>
         <p:spPr>
           <a:xfrm>
-            <a:off x="3133874" y="4724400"/>
+            <a:off x="3053432" y="4724400"/>
             <a:ext cx="57150" cy="57150"/>
           </a:xfrm>
           <a:prstGeom prst="roundRect">
@@ -17384,7 +17384,7 @@
         </p:nvSpPr>
         <p:spPr>
           <a:xfrm>
-            <a:off x="3238649" y="4724400"/>
+            <a:off x="3158207" y="4724400"/>
             <a:ext cx="57150" cy="57150"/>
           </a:xfrm>
           <a:prstGeom prst="roundRect">
@@ -17406,7 +17406,7 @@
         </p:nvSpPr>
         <p:spPr>
           <a:xfrm>
-            <a:off x="3343424" y="4724400"/>
+            <a:off x="3262982" y="4724400"/>
             <a:ext cx="171450" cy="57150"/>
           </a:xfrm>
           <a:prstGeom prst="roundRect">
@@ -17428,7 +17428,7 @@
         </p:nvSpPr>
         <p:spPr>
           <a:xfrm>
-            <a:off x="3562499" y="4724400"/>
+            <a:off x="3482057" y="4724400"/>
             <a:ext cx="57150" cy="57150"/>
           </a:xfrm>
           <a:prstGeom prst="roundRect">
@@ -17450,7 +17450,7 @@
         </p:nvSpPr>
         <p:spPr>
           <a:xfrm>
-            <a:off x="3667274" y="4724400"/>
+            <a:off x="3586832" y="4724400"/>
             <a:ext cx="57150" cy="57150"/>
           </a:xfrm>
           <a:prstGeom prst="roundRect">
@@ -19123,7 +19123,7 @@
                 <a:ea typeface="Pridi" pitchFamily="34" charset="-122"/>
                 <a:cs typeface="Pridi" pitchFamily="34" charset="-120"/>
               </a:rPr>
-              <a:t>บทที่ 6: การเข้าถึงและขยายสู่ระดับโลก</a:t>
+              <a:t>บทที่ 6: Global Reach &amp; Scale</a:t>
             </a:r>
             <a:endParaRPr lang="en-US" sz="2175" dirty="0"/>
           </a:p>
@@ -19165,7 +19165,7 @@
                 <a:ea typeface="Sarabun" pitchFamily="34" charset="-122"/>
                 <a:cs typeface="Sarabun" pitchFamily="34" charset="-120"/>
               </a:rPr>
-              <a:t>ขยายเรื่องเล่าข้ามพรมแดน</a:t>
+              <a:t>ขยาย Narrative ข้ามพรมแดน</a:t>
             </a:r>
             <a:endParaRPr lang="en-US" sz="1200" dirty="0"/>
           </a:p>
@@ -19207,7 +19207,7 @@
                 <a:ea typeface="Sarabun" pitchFamily="34" charset="-122"/>
                 <a:cs typeface="Sarabun" pitchFamily="34" charset="-120"/>
               </a:rPr>
-              <a:t>ตอนที่ 4 · ผลกระทบระดับโลก</a:t>
+              <a:t>Part 4 · Global Impact</a:t>
             </a:r>
             <a:endParaRPr lang="en-US" sz="900" dirty="0"/>
           </a:p>
@@ -19271,7 +19271,7 @@
                 <a:ea typeface="Sarabun" pitchFamily="34" charset="-122"/>
                 <a:cs typeface="Sarabun" pitchFamily="34" charset="-120"/>
               </a:rPr>
-              <a:t>การขยายสู่ระดับโลก</a:t>
+              <a:t>Global Reach &amp; Scale</a:t>
             </a:r>
             <a:endParaRPr lang="en-US" sz="900" dirty="0"/>
           </a:p>
@@ -19583,7 +19583,7 @@
                 <a:ea typeface="Sarabun" pitchFamily="34" charset="-122"/>
                 <a:cs typeface="Sarabun" pitchFamily="34" charset="-120"/>
               </a:rPr>
-              <a:t>กลยุทธ์การเติบโตหลัก</a:t>
+              <a:t>Key growth strategy</a:t>
             </a:r>
             <a:endParaRPr lang="en-US" sz="900" dirty="0"/>
           </a:p>
@@ -19671,7 +19671,7 @@
                 <a:ea typeface="Pridi" pitchFamily="34" charset="-122"/>
                 <a:cs typeface="Pridi" pitchFamily="34" charset="-120"/>
               </a:rPr>
-              <a:t>ร่วมทุนเชิงกลยุทธ์</a:t>
+              <a:t>Strategic joint ventures</a:t>
             </a:r>
             <a:endParaRPr lang="en-US" sz="1200" dirty="0"/>
           </a:p>
@@ -19713,7 +19713,7 @@
                 <a:ea typeface="Sarabun" pitchFamily="34" charset="-122"/>
                 <a:cs typeface="Sarabun" pitchFamily="34" charset="-120"/>
               </a:rPr>
-              <a:t>จับมือพันธมิตรท้องถิ่นเพื่อเข้าสู่และเติบโตในตลาดใหม่</a:t>
+              <a:t>จับมือ Partner ท้องถิ่นเพื่อเข้าสู่และเติบโตในตลาดใหม่</a:t>
             </a:r>
             <a:endParaRPr lang="en-US" sz="975" dirty="0"/>
           </a:p>
@@ -19801,7 +19801,7 @@
                 <a:ea typeface="Pridi" pitchFamily="34" charset="-122"/>
                 <a:cs typeface="Pridi" pitchFamily="34" charset="-120"/>
               </a:rPr>
-              <a:t>ปรับให้เข้ากับแต่ละตลาด</a:t>
+              <a:t>Market customization</a:t>
             </a:r>
             <a:endParaRPr lang="en-US" sz="1200" dirty="0"/>
           </a:p>
@@ -19843,7 +19843,7 @@
                 <a:ea typeface="Sarabun" pitchFamily="34" charset="-122"/>
                 <a:cs typeface="Sarabun" pitchFamily="34" charset="-120"/>
               </a:rPr>
-              <a:t>เมนูท้องถิ่น เช่น Teavana และเครื่องดื่มมัทฉะในเอเชีย</a:t>
+              <a:t>เมนูท้องถิ่น เช่น Teavana และเครื่องดื่ม Matcha ในเอเชีย</a:t>
             </a:r>
             <a:endParaRPr lang="en-US" sz="975" dirty="0"/>
           </a:p>
@@ -19973,7 +19973,7 @@
                 <a:ea typeface="Sarabun" pitchFamily="34" charset="-122"/>
                 <a:cs typeface="Sarabun" pitchFamily="34" charset="-120"/>
               </a:rPr>
-              <a:t>ร้านแฟล็กชิประดับไฮเอนด์ที่ทำหน้าที่เป็นนักเล่าเรื่องของแบรนด์</a:t>
+              <a:t>Flagship ระดับ High-End ที่ทำหน้าที่เป็น Storyteller ของแบรนด์</a:t>
             </a:r>
             <a:endParaRPr lang="en-US" sz="975" dirty="0"/>
           </a:p>
@@ -20057,7 +20057,7 @@
                 <a:ea typeface="Sarabun" pitchFamily="34" charset="-122"/>
                 <a:cs typeface="Sarabun" pitchFamily="34" charset="-120"/>
               </a:rPr>
-              <a:t>แล้ว</a:t>
+              <a:t>แล้ว </a:t>
             </a:r>
             <a:pPr algn="l" indent="0" marL="0">
               <a:lnSpc>
@@ -20074,7 +20074,7 @@
                 <a:ea typeface="Sarabun" pitchFamily="34" charset="-122"/>
                 <a:cs typeface="Sarabun" pitchFamily="34" charset="-120"/>
               </a:rPr>
-              <a:t>ผู้นำธุรกิจ</a:t>
+              <a:t>Business Leader</a:t>
             </a:r>
             <a:pPr algn="l" indent="0" marL="0">
               <a:lnSpc>
@@ -20091,7 +20091,7 @@
                 <a:ea typeface="Sarabun" pitchFamily="34" charset="-122"/>
                 <a:cs typeface="Sarabun" pitchFamily="34" charset="-120"/>
               </a:rPr>
-              <a:t>เรียนรู้อะไรได้บ้างจากเรื่องราวนี้?</a:t>
+              <a:t> เรียนรู้อะไรได้บ้างจากเรื่องราวนี้?</a:t>
             </a:r>
             <a:endParaRPr lang="en-US" sz="1013" dirty="0"/>
           </a:p>
@@ -20155,7 +20155,7 @@
                 <a:ea typeface="Sarabun" pitchFamily="34" charset="-122"/>
                 <a:cs typeface="Sarabun" pitchFamily="34" charset="-120"/>
               </a:rPr>
-              <a:t>บทเรียนสำหรับผู้นำธุรกิจ</a:t>
+              <a:t>บทเรียนสำหรับ Business Leaders</a:t>
             </a:r>
             <a:endParaRPr lang="en-US" sz="900" dirty="0"/>
           </a:p>
@@ -20170,7 +20170,7 @@
         <p:spPr>
           <a:xfrm>
             <a:off x="609600" y="4667250"/>
-            <a:ext cx="2083817" cy="171450"/>
+            <a:ext cx="1797174" cy="171450"/>
           </a:xfrm>
           <a:prstGeom prst="rect">
             <a:avLst/>
@@ -20197,7 +20197,7 @@
                 <a:ea typeface="Sarabun" pitchFamily="34" charset="-122"/>
                 <a:cs typeface="Sarabun" pitchFamily="34" charset="-120"/>
               </a:rPr>
-              <a:t>สไลด์ 7 จาก 8 · ตอนที่ 4 · ผลกระทบระดับโลก</a:t>
+              <a:t>สไลด์ 7 จาก 8 · Part 4 · Global Impact</a:t>
             </a:r>
             <a:endParaRPr lang="en-US" sz="900" dirty="0"/>
           </a:p>
@@ -20211,7 +20211,7 @@
         </p:nvSpPr>
         <p:spPr>
           <a:xfrm>
-            <a:off x="2883917" y="4724400"/>
+            <a:off x="2597274" y="4724400"/>
             <a:ext cx="57150" cy="57150"/>
           </a:xfrm>
           <a:prstGeom prst="roundRect">
@@ -20233,7 +20233,7 @@
         </p:nvSpPr>
         <p:spPr>
           <a:xfrm>
-            <a:off x="2988692" y="4724400"/>
+            <a:off x="2702049" y="4724400"/>
             <a:ext cx="57150" cy="57150"/>
           </a:xfrm>
           <a:prstGeom prst="roundRect">
@@ -20255,7 +20255,7 @@
         </p:nvSpPr>
         <p:spPr>
           <a:xfrm>
-            <a:off x="3093467" y="4724400"/>
+            <a:off x="2806824" y="4724400"/>
             <a:ext cx="57150" cy="57150"/>
           </a:xfrm>
           <a:prstGeom prst="roundRect">
@@ -20277,7 +20277,7 @@
         </p:nvSpPr>
         <p:spPr>
           <a:xfrm>
-            <a:off x="3198242" y="4724400"/>
+            <a:off x="2911599" y="4724400"/>
             <a:ext cx="57150" cy="57150"/>
           </a:xfrm>
           <a:prstGeom prst="roundRect">
@@ -20299,7 +20299,7 @@
         </p:nvSpPr>
         <p:spPr>
           <a:xfrm>
-            <a:off x="3303017" y="4724400"/>
+            <a:off x="3016374" y="4724400"/>
             <a:ext cx="57150" cy="57150"/>
           </a:xfrm>
           <a:prstGeom prst="roundRect">
@@ -20321,7 +20321,7 @@
         </p:nvSpPr>
         <p:spPr>
           <a:xfrm>
-            <a:off x="3407792" y="4724400"/>
+            <a:off x="3121149" y="4724400"/>
             <a:ext cx="57150" cy="57150"/>
           </a:xfrm>
           <a:prstGeom prst="roundRect">
@@ -20343,7 +20343,7 @@
         </p:nvSpPr>
         <p:spPr>
           <a:xfrm>
-            <a:off x="3512567" y="4724400"/>
+            <a:off x="3225924" y="4724400"/>
             <a:ext cx="171450" cy="57150"/>
           </a:xfrm>
           <a:prstGeom prst="roundRect">
@@ -20365,7 +20365,7 @@
         </p:nvSpPr>
         <p:spPr>
           <a:xfrm>
-            <a:off x="3731642" y="4724400"/>
+            <a:off x="3444999" y="4724400"/>
             <a:ext cx="57150" cy="57150"/>
           </a:xfrm>
           <a:prstGeom prst="roundRect">
@@ -21889,7 +21889,7 @@
                 <a:ea typeface="Pridi" pitchFamily="34" charset="-122"/>
                 <a:cs typeface="Pridi" pitchFamily="34" charset="-120"/>
               </a:rPr>
-              <a:t>บทเรียนทางธุรกิจที่สำคัญและบทสรุป</a:t>
+              <a:t>บทเรียนทางธุรกิจที่สำคัญ &amp; สรุป</a:t>
             </a:r>
             <a:endParaRPr lang="en-US" sz="2175" dirty="0"/>
           </a:p>
@@ -21931,7 +21931,7 @@
                 <a:ea typeface="Sarabun" pitchFamily="34" charset="-122"/>
                 <a:cs typeface="Sarabun" pitchFamily="34" charset="-120"/>
               </a:rPr>
-              <a:t>สิ่งที่ผู้นำธุรกิจเรียนรู้ได้จากสตาร์บัคส์</a:t>
+              <a:t>สิ่งที่ Business Leader เรียนรู้ได้จาก Starbucks</a:t>
             </a:r>
             <a:endParaRPr lang="en-US" sz="1200" dirty="0"/>
           </a:p>
@@ -21973,7 +21973,7 @@
                 <a:ea typeface="Sarabun" pitchFamily="34" charset="-122"/>
                 <a:cs typeface="Sarabun" pitchFamily="34" charset="-120"/>
               </a:rPr>
-              <a:t>ตอนที่ 4 · บทสรุปและข้อคิดสำหรับ MBA</a:t>
+              <a:t>Part 4 · บทสรุป &amp; MBA Takeaways</a:t>
             </a:r>
             <a:endParaRPr lang="en-US" sz="900" dirty="0"/>
           </a:p>
@@ -22037,7 +22037,7 @@
                 <a:ea typeface="Sarabun" pitchFamily="34" charset="-122"/>
                 <a:cs typeface="Sarabun" pitchFamily="34" charset="-120"/>
               </a:rPr>
-              <a:t>บทเรียนสำหรับผู้นำธุรกิจ</a:t>
+              <a:t>บทเรียนสำหรับ Business Leaders</a:t>
             </a:r>
             <a:endParaRPr lang="en-US" sz="900" dirty="0"/>
           </a:p>
@@ -22155,7 +22155,7 @@
                 <a:ea typeface="Pridi" pitchFamily="34" charset="-122"/>
                 <a:cs typeface="Pridi" pitchFamily="34" charset="-120"/>
               </a:rPr>
-              <a:t>ผลิตภัณฑ์ vs. ประสบการณ์</a:t>
+              <a:t>Product vs. Experience</a:t>
             </a:r>
             <a:endParaRPr lang="en-US" sz="1275" dirty="0"/>
           </a:p>
@@ -22197,7 +22197,7 @@
                 <a:ea typeface="Sarabun" pitchFamily="34" charset="-122"/>
                 <a:cs typeface="Sarabun" pitchFamily="34" charset="-120"/>
               </a:rPr>
-              <a:t>ผลิตภัณฑ์ถูกทำให้เป็นสินค้าโภคภัณฑ์ได้ แต่ประสบการณ์แบรนด์สร้างคูเมืองทางการแข่งขัน</a:t>
+              <a:t>Product ถูกทำให้เป็น Commodity ได้ แต่ Brand Experience สร้าง Competitive Moat</a:t>
             </a:r>
             <a:endParaRPr lang="en-US" sz="1013" dirty="0"/>
           </a:p>
@@ -22315,7 +22315,7 @@
                 <a:ea typeface="Pridi" pitchFamily="34" charset="-122"/>
                 <a:cs typeface="Pridi" pitchFamily="34" charset="-120"/>
               </a:rPr>
-              <a:t>ความจริงใจและความสม่ำเสมอ</a:t>
+              <a:t>Authenticity &amp; Consistency</a:t>
             </a:r>
             <a:endParaRPr lang="en-US" sz="1275" dirty="0"/>
           </a:p>
@@ -22357,7 +22357,7 @@
                 <a:ea typeface="Sarabun" pitchFamily="34" charset="-122"/>
                 <a:cs typeface="Sarabun" pitchFamily="34" charset="-120"/>
               </a:rPr>
-              <a:t>คุณค่าหลักของแบรนด์ต้องคงที่ แม้ขยายตัวทั่วโลกอย่างรวดเร็ว</a:t>
+              <a:t>Core Brand Values ต้องคงที่ แม้ขยายทั่วโลกอย่างรวดเร็ว</a:t>
             </a:r>
             <a:endParaRPr lang="en-US" sz="1013" dirty="0"/>
           </a:p>
@@ -22448,7 +22448,7 @@
         <p:spPr>
           <a:xfrm>
             <a:off x="6129338" y="2052637"/>
-            <a:ext cx="2337816" cy="453330"/>
+            <a:ext cx="2427732" cy="226665"/>
           </a:xfrm>
           <a:prstGeom prst="rect">
             <a:avLst/>
@@ -22457,7 +22457,7 @@
           <a:ln/>
         </p:spPr>
         <p:txBody>
-          <a:bodyPr wrap="square" lIns="0" tIns="0" rIns="0" bIns="0" rtlCol="0" anchor="t"/>
+          <a:bodyPr wrap="none" lIns="0" tIns="0" rIns="0" bIns="0" rtlCol="0" anchor="ctr"/>
           <a:lstStyle/>
           <a:p>
             <a:pPr algn="l" indent="0" marL="0">
@@ -22475,7 +22475,7 @@
                 <a:ea typeface="Pridi" pitchFamily="34" charset="-122"/>
                 <a:cs typeface="Pridi" pitchFamily="34" charset="-120"/>
               </a:rPr>
-              <a:t>ความสามารถในการปรับตัวเชิงกลยุทธ์</a:t>
+              <a:t>Strategic Adaptability</a:t>
             </a:r>
             <a:endParaRPr lang="en-US" sz="1275" dirty="0"/>
           </a:p>
@@ -22489,8 +22489,8 @@
         </p:nvSpPr>
         <p:spPr>
           <a:xfrm>
-            <a:off x="6129338" y="2553593"/>
-            <a:ext cx="2337816" cy="398562"/>
+            <a:off x="6129338" y="2326928"/>
+            <a:ext cx="2337816" cy="597843"/>
           </a:xfrm>
           <a:prstGeom prst="rect">
             <a:avLst/>
@@ -22517,7 +22517,7 @@
                 <a:ea typeface="Sarabun" pitchFamily="34" charset="-122"/>
                 <a:cs typeface="Sarabun" pitchFamily="34" charset="-120"/>
               </a:rPr>
-              <a:t>ผสานบรรยากาศบ้านหลังที่สามเข้ากับระบบนิเวศดิจิทัลล้ำสมัย</a:t>
+              <a:t>ผสานบรรยากาศ Third Place แบบ Physical เข้ากับ Digital Ecosystem ที่ล้ำสมัย</a:t>
             </a:r>
             <a:endParaRPr lang="en-US" sz="1013" dirty="0"/>
           </a:p>
@@ -22623,7 +22623,7 @@
                 <a:ea typeface="Pridi" pitchFamily="34" charset="-122"/>
                 <a:cs typeface="Pridi" pitchFamily="34" charset="-120"/>
               </a:rPr>
-              <a:t>ในโลกที่เป็นดิจิทัลและโดดเดี่ยวมากขึ้นทุกที ความโหยหาการเชื่อมโยงที่แท้จริงระหว่างมนุษย์ไม่เคยยิ่งใหญ่เท่านี้มาก่อน</a:t>
+              <a:t>ในโลกที่ Digital และโดดเดี่ยวมากขึ้นทุกที ความโหยหา Human Connection ที่แท้จริงไม่เคยยิ่งใหญ่เท่านี้มาก่อน</a:t>
             </a:r>
             <a:endParaRPr lang="en-US" sz="1200" dirty="0"/>
           </a:p>
@@ -22704,7 +22704,7 @@
         <p:spPr>
           <a:xfrm>
             <a:off x="609600" y="4667250"/>
-            <a:ext cx="2135609" cy="171450"/>
+            <a:ext cx="1744787" cy="171450"/>
           </a:xfrm>
           <a:prstGeom prst="rect">
             <a:avLst/>
@@ -22731,7 +22731,7 @@
                 <a:ea typeface="Sarabun" pitchFamily="34" charset="-122"/>
                 <a:cs typeface="Sarabun" pitchFamily="34" charset="-120"/>
               </a:rPr>
-              <a:t>สไลด์ 8 จาก 8 · ตอนที่ 4 · บทเรียนสำหรับ MBA</a:t>
+              <a:t>สไลด์ 8 จาก 8 · Part 4 · MBA Lessons</a:t>
             </a:r>
             <a:endParaRPr lang="en-US" sz="900" dirty="0"/>
           </a:p>
@@ -22745,7 +22745,7 @@
         </p:nvSpPr>
         <p:spPr>
           <a:xfrm>
-            <a:off x="2935709" y="4724400"/>
+            <a:off x="2544887" y="4724400"/>
             <a:ext cx="57150" cy="57150"/>
           </a:xfrm>
           <a:prstGeom prst="roundRect">
@@ -22767,7 +22767,7 @@
         </p:nvSpPr>
         <p:spPr>
           <a:xfrm>
-            <a:off x="3040484" y="4724400"/>
+            <a:off x="2649662" y="4724400"/>
             <a:ext cx="57150" cy="57150"/>
           </a:xfrm>
           <a:prstGeom prst="roundRect">
@@ -22789,7 +22789,7 @@
         </p:nvSpPr>
         <p:spPr>
           <a:xfrm>
-            <a:off x="3145259" y="4724400"/>
+            <a:off x="2754437" y="4724400"/>
             <a:ext cx="57150" cy="57150"/>
           </a:xfrm>
           <a:prstGeom prst="roundRect">
@@ -22811,7 +22811,7 @@
         </p:nvSpPr>
         <p:spPr>
           <a:xfrm>
-            <a:off x="3250034" y="4724400"/>
+            <a:off x="2859212" y="4724400"/>
             <a:ext cx="57150" cy="57150"/>
           </a:xfrm>
           <a:prstGeom prst="roundRect">
@@ -22833,7 +22833,7 @@
         </p:nvSpPr>
         <p:spPr>
           <a:xfrm>
-            <a:off x="3354809" y="4724400"/>
+            <a:off x="2963987" y="4724400"/>
             <a:ext cx="57150" cy="57150"/>
           </a:xfrm>
           <a:prstGeom prst="roundRect">
@@ -22855,7 +22855,7 @@
         </p:nvSpPr>
         <p:spPr>
           <a:xfrm>
-            <a:off x="3459584" y="4724400"/>
+            <a:off x="3068762" y="4724400"/>
             <a:ext cx="57150" cy="57150"/>
           </a:xfrm>
           <a:prstGeom prst="roundRect">
@@ -22877,7 +22877,7 @@
         </p:nvSpPr>
         <p:spPr>
           <a:xfrm>
-            <a:off x="3564359" y="4724400"/>
+            <a:off x="3173537" y="4724400"/>
             <a:ext cx="57150" cy="57150"/>
           </a:xfrm>
           <a:prstGeom prst="roundRect">
@@ -22899,7 +22899,7 @@
         </p:nvSpPr>
         <p:spPr>
           <a:xfrm>
-            <a:off x="3669134" y="4724400"/>
+            <a:off x="3278312" y="4724400"/>
             <a:ext cx="171450" cy="57150"/>
           </a:xfrm>
           <a:prstGeom prst="roundRect">
@@ -43631,7 +43631,7 @@
                 <a:ea typeface="Sarabun" pitchFamily="34" charset="-122"/>
                 <a:cs typeface="Sarabun" pitchFamily="34" charset="-120"/>
               </a:rPr>
-              <a:t>วิชาธุรกิจ MBA · การนำเสนอกลุ่ม</a:t>
+              <a:t>MBA Business Class · Group Presentation</a:t>
             </a:r>
             <a:endParaRPr lang="en-US" sz="900" dirty="0"/>
           </a:p>
@@ -43673,7 +43673,7 @@
                 <a:ea typeface="Pridi" pitchFamily="34" charset="-122"/>
                 <a:cs typeface="Pridi" pitchFamily="34" charset="-120"/>
               </a:rPr>
-              <a:t>สร้างวัฒนธรรมระดับโลก: มาสเตอร์คลาสการเล่าเรื่องของสตาร์บัคส์</a:t>
+              <a:t>สร้างวัฒนธรรมระดับโลก: Storytelling Masterclass ของ Starbucks</a:t>
             </a:r>
             <a:endParaRPr lang="en-US" sz="2475" dirty="0"/>
           </a:p>
@@ -43715,7 +43715,7 @@
                 <a:ea typeface="Sarabun" pitchFamily="34" charset="-122"/>
                 <a:cs typeface="Sarabun" pitchFamily="34" charset="-120"/>
               </a:rPr>
-              <a:t>เรื่องเล่า ประสบการณ์ และอัตลักษณ์ สร้างอาณาจักรมูลค่าหลายพันล้านดอลลาร์ได้อย่างไร</a:t>
+              <a:t>Narrative, Experience และ Identity สร้างอาณาจักรมูลค่าหลายพันล้านดอลลาร์ได้อย่างไร</a:t>
             </a:r>
             <a:endParaRPr lang="en-US" sz="1200" dirty="0"/>
           </a:p>
@@ -43923,7 +43923,7 @@
                 <a:ea typeface="Pridi" pitchFamily="34" charset="-122"/>
                 <a:cs typeface="Pridi" pitchFamily="34" charset="-120"/>
               </a:rPr>
-              <a:t>ตลาดไพก์เพลซ ซีแอตเทิล</a:t>
+              <a:t>Pike Place Market, Seattle</a:t>
             </a:r>
             <a:endParaRPr lang="en-US" sz="1275" dirty="0"/>
           </a:p>
@@ -44078,7 +44078,7 @@
                 <a:ea typeface="Pridi" pitchFamily="34" charset="-122"/>
                 <a:cs typeface="Pridi" pitchFamily="34" charset="-120"/>
               </a:rPr>
-              <a:t>กาแฟเมล็ดคั่วระดับกูร์เมต์</a:t>
+              <a:t>Whole-Bean Gourmet Coffee</a:t>
             </a:r>
             <a:endParaRPr lang="en-US" sz="1275" dirty="0"/>
           </a:p>
@@ -44233,7 +44233,7 @@
                 <a:ea typeface="Pridi" pitchFamily="34" charset="-122"/>
                 <a:cs typeface="Pridi" pitchFamily="34" charset="-120"/>
               </a:rPr>
-              <a:t>ไซเรนสองหางจากตำนานนอร์ส</a:t>
+              <a:t>Siren สองหางจากตำนาน Norse</a:t>
             </a:r>
             <a:endParaRPr lang="en-US" sz="1275" dirty="0"/>
           </a:p>
@@ -44317,7 +44317,7 @@
                 <a:ea typeface="Sarabun" pitchFamily="34" charset="-122"/>
                 <a:cs typeface="Sarabun" pitchFamily="34" charset="-120"/>
               </a:rPr>
-              <a:t>ต่อไป เรามาดูกันว่าทุกอย่างเริ่มต้นที่ไหนในปี </a:t>
+              <a:t>ต่อไป มาดูกันว่าทุกอย่างเริ่มต้นที่ไหนในปี </a:t>
             </a:r>
             <a:pPr algn="l" indent="0" marL="0">
               <a:lnSpc>
@@ -44415,7 +44415,7 @@
                 <a:ea typeface="Sarabun" pitchFamily="34" charset="-122"/>
                 <a:cs typeface="Sarabun" pitchFamily="34" charset="-120"/>
               </a:rPr>
-              <a:t>1971 · ไพก์เพลซ ซีแอตเทิล</a:t>
+              <a:t>1971 · Pike Place, Seattle</a:t>
             </a:r>
             <a:endParaRPr lang="en-US" sz="900" dirty="0"/>
           </a:p>
@@ -44430,7 +44430,7 @@
         <p:spPr>
           <a:xfrm>
             <a:off x="609600" y="4667250"/>
-            <a:ext cx="2170584" cy="171450"/>
+            <a:ext cx="2612678" cy="171450"/>
           </a:xfrm>
           <a:prstGeom prst="rect">
             <a:avLst/>
@@ -44457,7 +44457,7 @@
                 <a:ea typeface="Sarabun" pitchFamily="34" charset="-122"/>
                 <a:cs typeface="Sarabun" pitchFamily="34" charset="-120"/>
               </a:rPr>
-              <a:t>สไลด์ 1 จาก 8 · ตอนที่ 1 · รากฐานและจุดกำเนิด</a:t>
+              <a:t>สไลด์ 1 จาก 8 · Part 1 · รากฐานและจุดกำเนิดของแบรนด์</a:t>
             </a:r>
             <a:endParaRPr lang="en-US" sz="900" dirty="0"/>
           </a:p>
@@ -44471,7 +44471,7 @@
         </p:nvSpPr>
         <p:spPr>
           <a:xfrm>
-            <a:off x="2970684" y="4724400"/>
+            <a:off x="3412778" y="4724400"/>
             <a:ext cx="171450" cy="57150"/>
           </a:xfrm>
           <a:prstGeom prst="roundRect">
@@ -44493,7 +44493,7 @@
         </p:nvSpPr>
         <p:spPr>
           <a:xfrm>
-            <a:off x="3189759" y="4724400"/>
+            <a:off x="3631853" y="4724400"/>
             <a:ext cx="57150" cy="57150"/>
           </a:xfrm>
           <a:prstGeom prst="roundRect">
@@ -44515,7 +44515,7 @@
         </p:nvSpPr>
         <p:spPr>
           <a:xfrm>
-            <a:off x="3294534" y="4724400"/>
+            <a:off x="3736628" y="4724400"/>
             <a:ext cx="57150" cy="57150"/>
           </a:xfrm>
           <a:prstGeom prst="roundRect">
@@ -44537,7 +44537,7 @@
         </p:nvSpPr>
         <p:spPr>
           <a:xfrm>
-            <a:off x="3399309" y="4724400"/>
+            <a:off x="3841403" y="4724400"/>
             <a:ext cx="57150" cy="57150"/>
           </a:xfrm>
           <a:prstGeom prst="roundRect">
@@ -44559,7 +44559,7 @@
         </p:nvSpPr>
         <p:spPr>
           <a:xfrm>
-            <a:off x="3504084" y="4724400"/>
+            <a:off x="3946178" y="4724400"/>
             <a:ext cx="57150" cy="57150"/>
           </a:xfrm>
           <a:prstGeom prst="roundRect">
@@ -44581,7 +44581,7 @@
         </p:nvSpPr>
         <p:spPr>
           <a:xfrm>
-            <a:off x="3608859" y="4724400"/>
+            <a:off x="4050953" y="4724400"/>
             <a:ext cx="57150" cy="57150"/>
           </a:xfrm>
           <a:prstGeom prst="roundRect">
@@ -44603,7 +44603,7 @@
         </p:nvSpPr>
         <p:spPr>
           <a:xfrm>
-            <a:off x="3713634" y="4724400"/>
+            <a:off x="4155728" y="4724400"/>
             <a:ext cx="57150" cy="57150"/>
           </a:xfrm>
           <a:prstGeom prst="roundRect">
@@ -44625,7 +44625,7 @@
         </p:nvSpPr>
         <p:spPr>
           <a:xfrm>
-            <a:off x="3818409" y="4724400"/>
+            <a:off x="4260503" y="4724400"/>
             <a:ext cx="57150" cy="57150"/>
           </a:xfrm>
           <a:prstGeom prst="roundRect">

</xml_diff>